<commit_message>
Update neuronify documents and add videos
</commit_message>
<xml_diff>
--- a/Neuronify.pptx
+++ b/Neuronify.pptx
@@ -4,12 +4,18 @@
   <p:sldMasterIdLst>
     <p:sldMasterId id="2147483648" r:id="rId4"/>
   </p:sldMasterIdLst>
+  <p:notesMasterIdLst>
+    <p:notesMasterId r:id="rId13"/>
+  </p:notesMasterIdLst>
   <p:sldIdLst>
     <p:sldId id="256" r:id="rId5"/>
-    <p:sldId id="257" r:id="rId6"/>
-    <p:sldId id="258" r:id="rId7"/>
-    <p:sldId id="259" r:id="rId8"/>
-    <p:sldId id="260" r:id="rId9"/>
+    <p:sldId id="264" r:id="rId6"/>
+    <p:sldId id="262" r:id="rId7"/>
+    <p:sldId id="263" r:id="rId8"/>
+    <p:sldId id="257" r:id="rId9"/>
+    <p:sldId id="258" r:id="rId10"/>
+    <p:sldId id="259" r:id="rId11"/>
+    <p:sldId id="260" r:id="rId12"/>
   </p:sldIdLst>
   <p:sldSz cx="12192000" cy="6858000"/>
   <p:notesSz cx="6858000" cy="9144000"/>
@@ -108,13 +114,18 @@
       </a:defRPr>
     </a:lvl9pPr>
   </p:defaultTextStyle>
+  <p:extLst>
+    <p:ext uri="{EFAFB233-063F-42B5-8137-9DF3F51BA10A}">
+      <p15:sldGuideLst xmlns:p15="http://schemas.microsoft.com/office/powerpoint/2012/main"/>
+    </p:ext>
+  </p:extLst>
 </p:presentation>
 </file>
 
 <file path=ppt/revisionInfo.xml><?xml version="1.0" encoding="utf-8"?>
 <p1510:revInfo xmlns:a="http://schemas.openxmlformats.org/drawingml/2006/main" xmlns:r="http://schemas.openxmlformats.org/officeDocument/2006/relationships" xmlns:p1510="http://schemas.microsoft.com/office/powerpoint/2015/10/main">
   <p1510:revLst>
-    <p1510:client id="{185C1959-A829-4BE8-AA4B-145F69D92391}" v="4" dt="2026-02-16T05:02:49.213"/>
+    <p1510:client id="{F511FE74-FE04-4361-8123-E714D1D7286E}" v="18" dt="2026-03-02T15:51:57.053"/>
   </p1510:revLst>
 </p1510:revInfo>
 </file>
@@ -142,14 +153,6 @@
             <ac:spMk id="8" creationId="{72999750-86A0-D703-C191-AB3FEBE82680}"/>
           </ac:spMkLst>
         </pc:spChg>
-        <pc:picChg chg="del">
-          <ac:chgData name="Mengyi Xu" userId="22b87d4f-9ef1-4603-b772-33dfde06a994" providerId="ADAL" clId="{DB32C877-22A6-4E69-A430-F54433E47030}" dt="2026-02-16T04:57:19.735" v="0" actId="478"/>
-          <ac:picMkLst>
-            <pc:docMk/>
-            <pc:sldMk cId="3098464200" sldId="257"/>
-            <ac:picMk id="5" creationId="{FB92ABF0-81E9-7E72-764E-A0F8E717389B}"/>
-          </ac:picMkLst>
-        </pc:picChg>
         <pc:picChg chg="add mod">
           <ac:chgData name="Mengyi Xu" userId="22b87d4f-9ef1-4603-b772-33dfde06a994" providerId="ADAL" clId="{DB32C877-22A6-4E69-A430-F54433E47030}" dt="2026-02-16T05:01:25.305" v="69" actId="1076"/>
           <ac:picMkLst>
@@ -165,22 +168,6 @@
           <pc:docMk/>
           <pc:sldMk cId="2928508640" sldId="258"/>
         </pc:sldMkLst>
-        <pc:spChg chg="del">
-          <ac:chgData name="Mengyi Xu" userId="22b87d4f-9ef1-4603-b772-33dfde06a994" providerId="ADAL" clId="{DB32C877-22A6-4E69-A430-F54433E47030}" dt="2026-02-16T04:57:41.955" v="5" actId="478"/>
-          <ac:spMkLst>
-            <pc:docMk/>
-            <pc:sldMk cId="2928508640" sldId="258"/>
-            <ac:spMk id="2" creationId="{20353C7F-059A-7A89-8E26-5F9019E0DA9E}"/>
-          </ac:spMkLst>
-        </pc:spChg>
-        <pc:spChg chg="del">
-          <ac:chgData name="Mengyi Xu" userId="22b87d4f-9ef1-4603-b772-33dfde06a994" providerId="ADAL" clId="{DB32C877-22A6-4E69-A430-F54433E47030}" dt="2026-02-16T04:57:40.276" v="4" actId="478"/>
-          <ac:spMkLst>
-            <pc:docMk/>
-            <pc:sldMk cId="2928508640" sldId="258"/>
-            <ac:spMk id="3" creationId="{4DE00E5B-262F-87A5-D210-E6E777285554}"/>
-          </ac:spMkLst>
-        </pc:spChg>
         <pc:spChg chg="add mod">
           <ac:chgData name="Mengyi Xu" userId="22b87d4f-9ef1-4603-b772-33dfde06a994" providerId="ADAL" clId="{DB32C877-22A6-4E69-A430-F54433E47030}" dt="2026-02-16T05:02:12.944" v="138" actId="20577"/>
           <ac:spMkLst>
@@ -204,22 +191,6 @@
           <pc:docMk/>
           <pc:sldMk cId="3671709465" sldId="259"/>
         </pc:sldMkLst>
-        <pc:spChg chg="del">
-          <ac:chgData name="Mengyi Xu" userId="22b87d4f-9ef1-4603-b772-33dfde06a994" providerId="ADAL" clId="{DB32C877-22A6-4E69-A430-F54433E47030}" dt="2026-02-16T04:59:42.211" v="11" actId="478"/>
-          <ac:spMkLst>
-            <pc:docMk/>
-            <pc:sldMk cId="3671709465" sldId="259"/>
-            <ac:spMk id="2" creationId="{817BFAD4-829E-2356-3C6E-7638F1EE9400}"/>
-          </ac:spMkLst>
-        </pc:spChg>
-        <pc:spChg chg="del">
-          <ac:chgData name="Mengyi Xu" userId="22b87d4f-9ef1-4603-b772-33dfde06a994" providerId="ADAL" clId="{DB32C877-22A6-4E69-A430-F54433E47030}" dt="2026-02-16T04:59:40.955" v="10" actId="478"/>
-          <ac:spMkLst>
-            <pc:docMk/>
-            <pc:sldMk cId="3671709465" sldId="259"/>
-            <ac:spMk id="3" creationId="{A6D49C31-112D-639A-1918-6D44DDF71F93}"/>
-          </ac:spMkLst>
-        </pc:spChg>
         <pc:spChg chg="add mod">
           <ac:chgData name="Mengyi Xu" userId="22b87d4f-9ef1-4603-b772-33dfde06a994" providerId="ADAL" clId="{DB32C877-22A6-4E69-A430-F54433E47030}" dt="2026-02-16T05:03:37.112" v="242" actId="20577"/>
           <ac:spMkLst>
@@ -243,22 +214,6 @@
           <pc:docMk/>
           <pc:sldMk cId="3504336953" sldId="260"/>
         </pc:sldMkLst>
-        <pc:spChg chg="del">
-          <ac:chgData name="Mengyi Xu" userId="22b87d4f-9ef1-4603-b772-33dfde06a994" providerId="ADAL" clId="{DB32C877-22A6-4E69-A430-F54433E47030}" dt="2026-02-16T05:00:06.971" v="18" actId="478"/>
-          <ac:spMkLst>
-            <pc:docMk/>
-            <pc:sldMk cId="3504336953" sldId="260"/>
-            <ac:spMk id="2" creationId="{2EC7533F-8655-B85F-9DC4-EB6B4FCC1D14}"/>
-          </ac:spMkLst>
-        </pc:spChg>
-        <pc:spChg chg="del">
-          <ac:chgData name="Mengyi Xu" userId="22b87d4f-9ef1-4603-b772-33dfde06a994" providerId="ADAL" clId="{DB32C877-22A6-4E69-A430-F54433E47030}" dt="2026-02-16T05:00:05.043" v="17" actId="478"/>
-          <ac:spMkLst>
-            <pc:docMk/>
-            <pc:sldMk cId="3504336953" sldId="260"/>
-            <ac:spMk id="3" creationId="{F4F9C3A7-0805-6935-E97F-C28082D12F36}"/>
-          </ac:spMkLst>
-        </pc:spChg>
         <pc:spChg chg="add mod">
           <ac:chgData name="Mengyi Xu" userId="22b87d4f-9ef1-4603-b772-33dfde06a994" providerId="ADAL" clId="{DB32C877-22A6-4E69-A430-F54433E47030}" dt="2026-02-16T05:03:32.232" v="241" actId="20577"/>
           <ac:spMkLst>
@@ -276,24 +231,1169 @@
           </ac:picMkLst>
         </pc:picChg>
       </pc:sldChg>
-      <pc:sldChg chg="modSp new del mod">
-        <pc:chgData name="Mengyi Xu" userId="22b87d4f-9ef1-4603-b772-33dfde06a994" providerId="ADAL" clId="{DB32C877-22A6-4E69-A430-F54433E47030}" dt="2026-02-16T05:03:42.229" v="243" actId="47"/>
+    </pc:docChg>
+  </pc:docChgLst>
+  <pc:docChgLst>
+    <pc:chgData name="Mengyi Xu" userId="22b87d4f-9ef1-4603-b772-33dfde06a994" providerId="ADAL" clId="{960FE0C6-57CF-4EA3-850D-CAAE7E95047B}"/>
+    <pc:docChg chg="undo custSel addSld delSld modSld">
+      <pc:chgData name="Mengyi Xu" userId="22b87d4f-9ef1-4603-b772-33dfde06a994" providerId="ADAL" clId="{960FE0C6-57CF-4EA3-850D-CAAE7E95047B}" dt="2026-03-02T16:40:03.992" v="511" actId="20577"/>
+      <pc:docMkLst>
+        <pc:docMk/>
+      </pc:docMkLst>
+      <pc:sldChg chg="modSp mod">
+        <pc:chgData name="Mengyi Xu" userId="22b87d4f-9ef1-4603-b772-33dfde06a994" providerId="ADAL" clId="{960FE0C6-57CF-4EA3-850D-CAAE7E95047B}" dt="2026-03-02T15:16:36.524" v="20" actId="20577"/>
         <pc:sldMkLst>
           <pc:docMk/>
-          <pc:sldMk cId="1709429631" sldId="261"/>
+          <pc:sldMk cId="2149487310" sldId="256"/>
         </pc:sldMkLst>
         <pc:spChg chg="mod">
-          <ac:chgData name="Mengyi Xu" userId="22b87d4f-9ef1-4603-b772-33dfde06a994" providerId="ADAL" clId="{DB32C877-22A6-4E69-A430-F54433E47030}" dt="2026-02-16T05:01:18.729" v="68" actId="20577"/>
+          <ac:chgData name="Mengyi Xu" userId="22b87d4f-9ef1-4603-b772-33dfde06a994" providerId="ADAL" clId="{960FE0C6-57CF-4EA3-850D-CAAE7E95047B}" dt="2026-03-02T15:16:36.524" v="20" actId="20577"/>
           <ac:spMkLst>
             <pc:docMk/>
-            <pc:sldMk cId="1709429631" sldId="261"/>
-            <ac:spMk id="2" creationId="{758947F7-D997-BDB1-D34F-DA74D6AC7405}"/>
+            <pc:sldMk cId="2149487310" sldId="256"/>
+            <ac:spMk id="3" creationId="{3BC8A41C-D4EA-C9CF-9082-3B8BDC15A1BC}"/>
           </ac:spMkLst>
         </pc:spChg>
+      </pc:sldChg>
+      <pc:sldChg chg="modNotesTx">
+        <pc:chgData name="Mengyi Xu" userId="22b87d4f-9ef1-4603-b772-33dfde06a994" providerId="ADAL" clId="{960FE0C6-57CF-4EA3-850D-CAAE7E95047B}" dt="2026-03-02T16:13:29.119" v="343" actId="20577"/>
+        <pc:sldMkLst>
+          <pc:docMk/>
+          <pc:sldMk cId="3098464200" sldId="257"/>
+        </pc:sldMkLst>
+      </pc:sldChg>
+      <pc:sldChg chg="addSp delSp mod modNotesTx">
+        <pc:chgData name="Mengyi Xu" userId="22b87d4f-9ef1-4603-b772-33dfde06a994" providerId="ADAL" clId="{960FE0C6-57CF-4EA3-850D-CAAE7E95047B}" dt="2026-03-02T16:39:46.102" v="448" actId="20577"/>
+        <pc:sldMkLst>
+          <pc:docMk/>
+          <pc:sldMk cId="3671709465" sldId="259"/>
+        </pc:sldMkLst>
+        <pc:picChg chg="add del">
+          <ac:chgData name="Mengyi Xu" userId="22b87d4f-9ef1-4603-b772-33dfde06a994" providerId="ADAL" clId="{960FE0C6-57CF-4EA3-850D-CAAE7E95047B}" dt="2026-03-02T16:36:38.906" v="345" actId="478"/>
+          <ac:picMkLst>
+            <pc:docMk/>
+            <pc:sldMk cId="3671709465" sldId="259"/>
+            <ac:picMk id="5" creationId="{C2A35471-10ED-349E-1910-DED5ADDF4773}"/>
+          </ac:picMkLst>
+        </pc:picChg>
+      </pc:sldChg>
+      <pc:sldChg chg="modNotesTx">
+        <pc:chgData name="Mengyi Xu" userId="22b87d4f-9ef1-4603-b772-33dfde06a994" providerId="ADAL" clId="{960FE0C6-57CF-4EA3-850D-CAAE7E95047B}" dt="2026-03-02T16:40:03.992" v="511" actId="20577"/>
+        <pc:sldMkLst>
+          <pc:docMk/>
+          <pc:sldMk cId="3504336953" sldId="260"/>
+        </pc:sldMkLst>
+      </pc:sldChg>
+      <pc:sldChg chg="addSp delSp modSp new del mod">
+        <pc:chgData name="Mengyi Xu" userId="22b87d4f-9ef1-4603-b772-33dfde06a994" providerId="ADAL" clId="{960FE0C6-57CF-4EA3-850D-CAAE7E95047B}" dt="2026-03-02T15:52:18.731" v="249" actId="47"/>
+        <pc:sldMkLst>
+          <pc:docMk/>
+          <pc:sldMk cId="522131507" sldId="261"/>
+        </pc:sldMkLst>
+        <pc:spChg chg="del">
+          <ac:chgData name="Mengyi Xu" userId="22b87d4f-9ef1-4603-b772-33dfde06a994" providerId="ADAL" clId="{960FE0C6-57CF-4EA3-850D-CAAE7E95047B}" dt="2026-03-02T15:30:20.985" v="22" actId="478"/>
+          <ac:spMkLst>
+            <pc:docMk/>
+            <pc:sldMk cId="522131507" sldId="261"/>
+            <ac:spMk id="3" creationId="{F9ACBD5B-A593-D868-545E-984FF1A1A0AC}"/>
+          </ac:spMkLst>
+        </pc:spChg>
+        <pc:spChg chg="add del mod">
+          <ac:chgData name="Mengyi Xu" userId="22b87d4f-9ef1-4603-b772-33dfde06a994" providerId="ADAL" clId="{960FE0C6-57CF-4EA3-850D-CAAE7E95047B}" dt="2026-03-02T15:51:32.351" v="229" actId="21"/>
+          <ac:spMkLst>
+            <pc:docMk/>
+            <pc:sldMk cId="522131507" sldId="261"/>
+            <ac:spMk id="6" creationId="{96E49410-10A4-50BC-6C4D-4FCE704D4034}"/>
+          </ac:spMkLst>
+        </pc:spChg>
+        <pc:spChg chg="add del mod">
+          <ac:chgData name="Mengyi Xu" userId="22b87d4f-9ef1-4603-b772-33dfde06a994" providerId="ADAL" clId="{960FE0C6-57CF-4EA3-850D-CAAE7E95047B}" dt="2026-03-02T15:37:06.340" v="64" actId="478"/>
+          <ac:spMkLst>
+            <pc:docMk/>
+            <pc:sldMk cId="522131507" sldId="261"/>
+            <ac:spMk id="7" creationId="{1497F566-F429-04C6-E278-06CD9BD0E41F}"/>
+          </ac:spMkLst>
+        </pc:spChg>
+        <pc:spChg chg="add del mod">
+          <ac:chgData name="Mengyi Xu" userId="22b87d4f-9ef1-4603-b772-33dfde06a994" providerId="ADAL" clId="{960FE0C6-57CF-4EA3-850D-CAAE7E95047B}" dt="2026-03-02T15:51:55.644" v="240" actId="21"/>
+          <ac:spMkLst>
+            <pc:docMk/>
+            <pc:sldMk cId="522131507" sldId="261"/>
+            <ac:spMk id="8" creationId="{993A12EB-B634-5603-6B34-63E74BE1EACE}"/>
+          </ac:spMkLst>
+        </pc:spChg>
+        <pc:picChg chg="add del mod modCrop">
+          <ac:chgData name="Mengyi Xu" userId="22b87d4f-9ef1-4603-b772-33dfde06a994" providerId="ADAL" clId="{960FE0C6-57CF-4EA3-850D-CAAE7E95047B}" dt="2026-03-02T15:51:32.351" v="229" actId="21"/>
+          <ac:picMkLst>
+            <pc:docMk/>
+            <pc:sldMk cId="522131507" sldId="261"/>
+            <ac:picMk id="4" creationId="{24778B04-BDD3-EEF3-2AAE-857954E3D6C1}"/>
+          </ac:picMkLst>
+        </pc:picChg>
+        <pc:picChg chg="add del mod modCrop">
+          <ac:chgData name="Mengyi Xu" userId="22b87d4f-9ef1-4603-b772-33dfde06a994" providerId="ADAL" clId="{960FE0C6-57CF-4EA3-850D-CAAE7E95047B}" dt="2026-03-02T15:51:55.644" v="240" actId="21"/>
+          <ac:picMkLst>
+            <pc:docMk/>
+            <pc:sldMk cId="522131507" sldId="261"/>
+            <ac:picMk id="5" creationId="{CAE98254-4312-6727-185B-50E76B9D305D}"/>
+          </ac:picMkLst>
+        </pc:picChg>
+      </pc:sldChg>
+      <pc:sldChg chg="addSp delSp modSp new mod">
+        <pc:chgData name="Mengyi Xu" userId="22b87d4f-9ef1-4603-b772-33dfde06a994" providerId="ADAL" clId="{960FE0C6-57CF-4EA3-850D-CAAE7E95047B}" dt="2026-03-02T15:39:32.390" v="211" actId="1076"/>
+        <pc:sldMkLst>
+          <pc:docMk/>
+          <pc:sldMk cId="4089420750" sldId="262"/>
+        </pc:sldMkLst>
+        <pc:spChg chg="del">
+          <ac:chgData name="Mengyi Xu" userId="22b87d4f-9ef1-4603-b772-33dfde06a994" providerId="ADAL" clId="{960FE0C6-57CF-4EA3-850D-CAAE7E95047B}" dt="2026-03-02T15:39:24.041" v="208" actId="478"/>
+          <ac:spMkLst>
+            <pc:docMk/>
+            <pc:sldMk cId="4089420750" sldId="262"/>
+            <ac:spMk id="3" creationId="{EFF7F3C9-3193-160F-27B4-6B064D0F1BDF}"/>
+          </ac:spMkLst>
+        </pc:spChg>
+        <pc:picChg chg="add mod">
+          <ac:chgData name="Mengyi Xu" userId="22b87d4f-9ef1-4603-b772-33dfde06a994" providerId="ADAL" clId="{960FE0C6-57CF-4EA3-850D-CAAE7E95047B}" dt="2026-03-02T15:39:32.390" v="211" actId="1076"/>
+          <ac:picMkLst>
+            <pc:docMk/>
+            <pc:sldMk cId="4089420750" sldId="262"/>
+            <ac:picMk id="1026" creationId="{5330B226-CC8A-6DD5-AD9C-61D5FFB7F4FF}"/>
+          </ac:picMkLst>
+        </pc:picChg>
+      </pc:sldChg>
+      <pc:sldChg chg="addSp delSp modSp new mod modNotesTx">
+        <pc:chgData name="Mengyi Xu" userId="22b87d4f-9ef1-4603-b772-33dfde06a994" providerId="ADAL" clId="{960FE0C6-57CF-4EA3-850D-CAAE7E95047B}" dt="2026-03-02T15:45:31.374" v="220" actId="20577"/>
+        <pc:sldMkLst>
+          <pc:docMk/>
+          <pc:sldMk cId="1346584351" sldId="263"/>
+        </pc:sldMkLst>
+        <pc:spChg chg="del">
+          <ac:chgData name="Mengyi Xu" userId="22b87d4f-9ef1-4603-b772-33dfde06a994" providerId="ADAL" clId="{960FE0C6-57CF-4EA3-850D-CAAE7E95047B}" dt="2026-03-02T15:40:21.625" v="213" actId="478"/>
+          <ac:spMkLst>
+            <pc:docMk/>
+            <pc:sldMk cId="1346584351" sldId="263"/>
+            <ac:spMk id="3" creationId="{A2359471-E77E-8A52-95E3-92131C87FCE0}"/>
+          </ac:spMkLst>
+        </pc:spChg>
+        <pc:picChg chg="add mod">
+          <ac:chgData name="Mengyi Xu" userId="22b87d4f-9ef1-4603-b772-33dfde06a994" providerId="ADAL" clId="{960FE0C6-57CF-4EA3-850D-CAAE7E95047B}" dt="2026-03-02T15:40:29.068" v="216" actId="1076"/>
+          <ac:picMkLst>
+            <pc:docMk/>
+            <pc:sldMk cId="1346584351" sldId="263"/>
+            <ac:picMk id="4" creationId="{AFF61227-20CE-0F4D-53E4-4EE0E60DFAE6}"/>
+          </ac:picMkLst>
+        </pc:picChg>
+      </pc:sldChg>
+      <pc:sldChg chg="addSp delSp modSp new mod">
+        <pc:chgData name="Mengyi Xu" userId="22b87d4f-9ef1-4603-b772-33dfde06a994" providerId="ADAL" clId="{960FE0C6-57CF-4EA3-850D-CAAE7E95047B}" dt="2026-03-02T15:57:23.689" v="267" actId="14100"/>
+        <pc:sldMkLst>
+          <pc:docMk/>
+          <pc:sldMk cId="140896304" sldId="264"/>
+        </pc:sldMkLst>
+        <pc:spChg chg="del">
+          <ac:chgData name="Mengyi Xu" userId="22b87d4f-9ef1-4603-b772-33dfde06a994" providerId="ADAL" clId="{960FE0C6-57CF-4EA3-850D-CAAE7E95047B}" dt="2026-03-02T15:51:02.824" v="225" actId="478"/>
+          <ac:spMkLst>
+            <pc:docMk/>
+            <pc:sldMk cId="140896304" sldId="264"/>
+            <ac:spMk id="3" creationId="{FE91D8EF-D9E0-3C15-E97F-25D379D7E1CB}"/>
+          </ac:spMkLst>
+        </pc:spChg>
+        <pc:spChg chg="add mod">
+          <ac:chgData name="Mengyi Xu" userId="22b87d4f-9ef1-4603-b772-33dfde06a994" providerId="ADAL" clId="{960FE0C6-57CF-4EA3-850D-CAAE7E95047B}" dt="2026-03-02T15:52:16.486" v="248" actId="1076"/>
+          <ac:spMkLst>
+            <pc:docMk/>
+            <pc:sldMk cId="140896304" sldId="264"/>
+            <ac:spMk id="6" creationId="{96E49410-10A4-50BC-6C4D-4FCE704D4034}"/>
+          </ac:spMkLst>
+        </pc:spChg>
+        <pc:spChg chg="add mod">
+          <ac:chgData name="Mengyi Xu" userId="22b87d4f-9ef1-4603-b772-33dfde06a994" providerId="ADAL" clId="{960FE0C6-57CF-4EA3-850D-CAAE7E95047B}" dt="2026-03-02T15:52:16.486" v="248" actId="1076"/>
+          <ac:spMkLst>
+            <pc:docMk/>
+            <pc:sldMk cId="140896304" sldId="264"/>
+            <ac:spMk id="8" creationId="{993A12EB-B634-5603-6B34-63E74BE1EACE}"/>
+          </ac:spMkLst>
+        </pc:spChg>
+        <pc:spChg chg="add mod">
+          <ac:chgData name="Mengyi Xu" userId="22b87d4f-9ef1-4603-b772-33dfde06a994" providerId="ADAL" clId="{960FE0C6-57CF-4EA3-850D-CAAE7E95047B}" dt="2026-03-02T15:53:51.940" v="255" actId="1582"/>
+          <ac:spMkLst>
+            <pc:docMk/>
+            <pc:sldMk cId="140896304" sldId="264"/>
+            <ac:spMk id="9" creationId="{1725C76B-5B8A-CBFF-C1F8-57A87E99BE2F}"/>
+          </ac:spMkLst>
+        </pc:spChg>
+        <pc:picChg chg="add mod">
+          <ac:chgData name="Mengyi Xu" userId="22b87d4f-9ef1-4603-b772-33dfde06a994" providerId="ADAL" clId="{960FE0C6-57CF-4EA3-850D-CAAE7E95047B}" dt="2026-03-02T15:53:15.545" v="251" actId="1076"/>
+          <ac:picMkLst>
+            <pc:docMk/>
+            <pc:sldMk cId="140896304" sldId="264"/>
+            <ac:picMk id="4" creationId="{C815FE92-8F83-ADE2-02EA-CC5D32C7A9A0}"/>
+          </ac:picMkLst>
+        </pc:picChg>
+        <pc:picChg chg="add mod">
+          <ac:chgData name="Mengyi Xu" userId="22b87d4f-9ef1-4603-b772-33dfde06a994" providerId="ADAL" clId="{960FE0C6-57CF-4EA3-850D-CAAE7E95047B}" dt="2026-03-02T15:52:16.486" v="248" actId="1076"/>
+          <ac:picMkLst>
+            <pc:docMk/>
+            <pc:sldMk cId="140896304" sldId="264"/>
+            <ac:picMk id="5" creationId="{24778B04-BDD3-EEF3-2AAE-857954E3D6C1}"/>
+          </ac:picMkLst>
+        </pc:picChg>
+        <pc:picChg chg="add mod">
+          <ac:chgData name="Mengyi Xu" userId="22b87d4f-9ef1-4603-b772-33dfde06a994" providerId="ADAL" clId="{960FE0C6-57CF-4EA3-850D-CAAE7E95047B}" dt="2026-03-02T15:52:16.486" v="248" actId="1076"/>
+          <ac:picMkLst>
+            <pc:docMk/>
+            <pc:sldMk cId="140896304" sldId="264"/>
+            <ac:picMk id="7" creationId="{CAE98254-4312-6727-185B-50E76B9D305D}"/>
+          </ac:picMkLst>
+        </pc:picChg>
+        <pc:cxnChg chg="add del mod">
+          <ac:chgData name="Mengyi Xu" userId="22b87d4f-9ef1-4603-b772-33dfde06a994" providerId="ADAL" clId="{960FE0C6-57CF-4EA3-850D-CAAE7E95047B}" dt="2026-03-02T15:54:49.971" v="261" actId="478"/>
+          <ac:cxnSpMkLst>
+            <pc:docMk/>
+            <pc:sldMk cId="140896304" sldId="264"/>
+            <ac:cxnSpMk id="11" creationId="{7AF09A4A-A7F8-BA06-560F-7CFB67C324E6}"/>
+          </ac:cxnSpMkLst>
+        </pc:cxnChg>
+        <pc:cxnChg chg="add mod">
+          <ac:chgData name="Mengyi Xu" userId="22b87d4f-9ef1-4603-b772-33dfde06a994" providerId="ADAL" clId="{960FE0C6-57CF-4EA3-850D-CAAE7E95047B}" dt="2026-03-02T15:57:23.689" v="267" actId="14100"/>
+          <ac:cxnSpMkLst>
+            <pc:docMk/>
+            <pc:sldMk cId="140896304" sldId="264"/>
+            <ac:cxnSpMk id="13" creationId="{CB360A81-42D5-6E03-ED66-5952EA497D3D}"/>
+          </ac:cxnSpMkLst>
+        </pc:cxnChg>
       </pc:sldChg>
     </pc:docChg>
   </pc:docChgLst>
 </pc:chgInfo>
+</file>
+
+<file path=ppt/notesMasters/notesMaster1.xml><?xml version="1.0" encoding="utf-8"?>
+<p:notesMaster xmlns:a="http://schemas.openxmlformats.org/drawingml/2006/main" xmlns:r="http://schemas.openxmlformats.org/officeDocument/2006/relationships" xmlns:p="http://schemas.openxmlformats.org/presentationml/2006/main">
+  <p:cSld>
+    <p:bg>
+      <p:bgRef idx="1001">
+        <a:schemeClr val="bg1"/>
+      </p:bgRef>
+    </p:bg>
+    <p:spTree>
+      <p:nvGrpSpPr>
+        <p:cNvPr id="1" name=""/>
+        <p:cNvGrpSpPr/>
+        <p:nvPr/>
+      </p:nvGrpSpPr>
+      <p:grpSpPr>
+        <a:xfrm>
+          <a:off x="0" y="0"/>
+          <a:ext cx="0" cy="0"/>
+          <a:chOff x="0" y="0"/>
+          <a:chExt cx="0" cy="0"/>
+        </a:xfrm>
+      </p:grpSpPr>
+      <p:sp>
+        <p:nvSpPr>
+          <p:cNvPr id="2" name="Header Placeholder 1"/>
+          <p:cNvSpPr>
+            <a:spLocks noGrp="1"/>
+          </p:cNvSpPr>
+          <p:nvPr>
+            <p:ph type="hdr" sz="quarter"/>
+          </p:nvPr>
+        </p:nvSpPr>
+        <p:spPr>
+          <a:xfrm>
+            <a:off x="0" y="0"/>
+            <a:ext cx="2971800" cy="458788"/>
+          </a:xfrm>
+          <a:prstGeom prst="rect">
+            <a:avLst/>
+          </a:prstGeom>
+        </p:spPr>
+        <p:txBody>
+          <a:bodyPr vert="horz" lIns="91440" tIns="45720" rIns="91440" bIns="45720" rtlCol="0"/>
+          <a:lstStyle>
+            <a:lvl1pPr algn="l">
+              <a:defRPr sz="1200"/>
+            </a:lvl1pPr>
+          </a:lstStyle>
+          <a:p>
+            <a:endParaRPr lang="en-CA"/>
+          </a:p>
+        </p:txBody>
+      </p:sp>
+      <p:sp>
+        <p:nvSpPr>
+          <p:cNvPr id="3" name="Date Placeholder 2"/>
+          <p:cNvSpPr>
+            <a:spLocks noGrp="1"/>
+          </p:cNvSpPr>
+          <p:nvPr>
+            <p:ph type="dt" idx="1"/>
+          </p:nvPr>
+        </p:nvSpPr>
+        <p:spPr>
+          <a:xfrm>
+            <a:off x="3884613" y="0"/>
+            <a:ext cx="2971800" cy="458788"/>
+          </a:xfrm>
+          <a:prstGeom prst="rect">
+            <a:avLst/>
+          </a:prstGeom>
+        </p:spPr>
+        <p:txBody>
+          <a:bodyPr vert="horz" lIns="91440" tIns="45720" rIns="91440" bIns="45720" rtlCol="0"/>
+          <a:lstStyle>
+            <a:lvl1pPr algn="r">
+              <a:defRPr sz="1200"/>
+            </a:lvl1pPr>
+          </a:lstStyle>
+          <a:p>
+            <a:fld id="{CD81AD10-EF72-4A34-841B-5B6708E6A358}" type="datetimeFigureOut">
+              <a:rPr lang="en-CA" smtClean="0"/>
+              <a:t>2026-03-02</a:t>
+            </a:fld>
+            <a:endParaRPr lang="en-CA"/>
+          </a:p>
+        </p:txBody>
+      </p:sp>
+      <p:sp>
+        <p:nvSpPr>
+          <p:cNvPr id="4" name="Slide Image Placeholder 3"/>
+          <p:cNvSpPr>
+            <a:spLocks noGrp="1" noRot="1" noChangeAspect="1"/>
+          </p:cNvSpPr>
+          <p:nvPr>
+            <p:ph type="sldImg" idx="2"/>
+          </p:nvPr>
+        </p:nvSpPr>
+        <p:spPr>
+          <a:xfrm>
+            <a:off x="685800" y="1143000"/>
+            <a:ext cx="5486400" cy="3086100"/>
+          </a:xfrm>
+          <a:prstGeom prst="rect">
+            <a:avLst/>
+          </a:prstGeom>
+          <a:noFill/>
+          <a:ln w="12700">
+            <a:solidFill>
+              <a:prstClr val="black"/>
+            </a:solidFill>
+          </a:ln>
+        </p:spPr>
+        <p:txBody>
+          <a:bodyPr vert="horz" lIns="91440" tIns="45720" rIns="91440" bIns="45720" rtlCol="0" anchor="ctr"/>
+          <a:lstStyle/>
+          <a:p>
+            <a:endParaRPr lang="en-CA"/>
+          </a:p>
+        </p:txBody>
+      </p:sp>
+      <p:sp>
+        <p:nvSpPr>
+          <p:cNvPr id="5" name="Notes Placeholder 4"/>
+          <p:cNvSpPr>
+            <a:spLocks noGrp="1"/>
+          </p:cNvSpPr>
+          <p:nvPr>
+            <p:ph type="body" sz="quarter" idx="3"/>
+          </p:nvPr>
+        </p:nvSpPr>
+        <p:spPr>
+          <a:xfrm>
+            <a:off x="685800" y="4400550"/>
+            <a:ext cx="5486400" cy="3600450"/>
+          </a:xfrm>
+          <a:prstGeom prst="rect">
+            <a:avLst/>
+          </a:prstGeom>
+        </p:spPr>
+        <p:txBody>
+          <a:bodyPr vert="horz" lIns="91440" tIns="45720" rIns="91440" bIns="45720" rtlCol="0"/>
+          <a:lstStyle/>
+          <a:p>
+            <a:pPr lvl="0"/>
+            <a:r>
+              <a:rPr lang="en-US"/>
+              <a:t>Click to edit Master text styles</a:t>
+            </a:r>
+          </a:p>
+          <a:p>
+            <a:pPr lvl="1"/>
+            <a:r>
+              <a:rPr lang="en-US"/>
+              <a:t>Second level</a:t>
+            </a:r>
+          </a:p>
+          <a:p>
+            <a:pPr lvl="2"/>
+            <a:r>
+              <a:rPr lang="en-US"/>
+              <a:t>Third level</a:t>
+            </a:r>
+          </a:p>
+          <a:p>
+            <a:pPr lvl="3"/>
+            <a:r>
+              <a:rPr lang="en-US"/>
+              <a:t>Fourth level</a:t>
+            </a:r>
+          </a:p>
+          <a:p>
+            <a:pPr lvl="4"/>
+            <a:r>
+              <a:rPr lang="en-US"/>
+              <a:t>Fifth level</a:t>
+            </a:r>
+            <a:endParaRPr lang="en-CA"/>
+          </a:p>
+        </p:txBody>
+      </p:sp>
+      <p:sp>
+        <p:nvSpPr>
+          <p:cNvPr id="6" name="Footer Placeholder 5"/>
+          <p:cNvSpPr>
+            <a:spLocks noGrp="1"/>
+          </p:cNvSpPr>
+          <p:nvPr>
+            <p:ph type="ftr" sz="quarter" idx="4"/>
+          </p:nvPr>
+        </p:nvSpPr>
+        <p:spPr>
+          <a:xfrm>
+            <a:off x="0" y="8685213"/>
+            <a:ext cx="2971800" cy="458787"/>
+          </a:xfrm>
+          <a:prstGeom prst="rect">
+            <a:avLst/>
+          </a:prstGeom>
+        </p:spPr>
+        <p:txBody>
+          <a:bodyPr vert="horz" lIns="91440" tIns="45720" rIns="91440" bIns="45720" rtlCol="0" anchor="b"/>
+          <a:lstStyle>
+            <a:lvl1pPr algn="l">
+              <a:defRPr sz="1200"/>
+            </a:lvl1pPr>
+          </a:lstStyle>
+          <a:p>
+            <a:endParaRPr lang="en-CA"/>
+          </a:p>
+        </p:txBody>
+      </p:sp>
+      <p:sp>
+        <p:nvSpPr>
+          <p:cNvPr id="7" name="Slide Number Placeholder 6"/>
+          <p:cNvSpPr>
+            <a:spLocks noGrp="1"/>
+          </p:cNvSpPr>
+          <p:nvPr>
+            <p:ph type="sldNum" sz="quarter" idx="5"/>
+          </p:nvPr>
+        </p:nvSpPr>
+        <p:spPr>
+          <a:xfrm>
+            <a:off x="3884613" y="8685213"/>
+            <a:ext cx="2971800" cy="458787"/>
+          </a:xfrm>
+          <a:prstGeom prst="rect">
+            <a:avLst/>
+          </a:prstGeom>
+        </p:spPr>
+        <p:txBody>
+          <a:bodyPr vert="horz" lIns="91440" tIns="45720" rIns="91440" bIns="45720" rtlCol="0" anchor="b"/>
+          <a:lstStyle>
+            <a:lvl1pPr algn="r">
+              <a:defRPr sz="1200"/>
+            </a:lvl1pPr>
+          </a:lstStyle>
+          <a:p>
+            <a:fld id="{D5DFF054-FCE2-473C-BAB8-AEC2ACD15967}" type="slidenum">
+              <a:rPr lang="en-CA" smtClean="0"/>
+              <a:t>‹#›</a:t>
+            </a:fld>
+            <a:endParaRPr lang="en-CA"/>
+          </a:p>
+        </p:txBody>
+      </p:sp>
+    </p:spTree>
+    <p:extLst>
+      <p:ext uri="{BB962C8B-B14F-4D97-AF65-F5344CB8AC3E}">
+        <p14:creationId xmlns:p14="http://schemas.microsoft.com/office/powerpoint/2010/main" val="3175966123"/>
+      </p:ext>
+    </p:extLst>
+  </p:cSld>
+  <p:clrMap bg1="lt1" tx1="dk1" bg2="lt2" tx2="dk2" accent1="accent1" accent2="accent2" accent3="accent3" accent4="accent4" accent5="accent5" accent6="accent6" hlink="hlink" folHlink="folHlink"/>
+  <p:notesStyle>
+    <a:lvl1pPr marL="0" algn="l" defTabSz="914400" rtl="0" eaLnBrk="1" latinLnBrk="0" hangingPunct="1">
+      <a:defRPr sz="1200" kern="1200">
+        <a:solidFill>
+          <a:schemeClr val="tx1"/>
+        </a:solidFill>
+        <a:latin typeface="+mn-lt"/>
+        <a:ea typeface="+mn-ea"/>
+        <a:cs typeface="+mn-cs"/>
+      </a:defRPr>
+    </a:lvl1pPr>
+    <a:lvl2pPr marL="457200" algn="l" defTabSz="914400" rtl="0" eaLnBrk="1" latinLnBrk="0" hangingPunct="1">
+      <a:defRPr sz="1200" kern="1200">
+        <a:solidFill>
+          <a:schemeClr val="tx1"/>
+        </a:solidFill>
+        <a:latin typeface="+mn-lt"/>
+        <a:ea typeface="+mn-ea"/>
+        <a:cs typeface="+mn-cs"/>
+      </a:defRPr>
+    </a:lvl2pPr>
+    <a:lvl3pPr marL="914400" algn="l" defTabSz="914400" rtl="0" eaLnBrk="1" latinLnBrk="0" hangingPunct="1">
+      <a:defRPr sz="1200" kern="1200">
+        <a:solidFill>
+          <a:schemeClr val="tx1"/>
+        </a:solidFill>
+        <a:latin typeface="+mn-lt"/>
+        <a:ea typeface="+mn-ea"/>
+        <a:cs typeface="+mn-cs"/>
+      </a:defRPr>
+    </a:lvl3pPr>
+    <a:lvl4pPr marL="1371600" algn="l" defTabSz="914400" rtl="0" eaLnBrk="1" latinLnBrk="0" hangingPunct="1">
+      <a:defRPr sz="1200" kern="1200">
+        <a:solidFill>
+          <a:schemeClr val="tx1"/>
+        </a:solidFill>
+        <a:latin typeface="+mn-lt"/>
+        <a:ea typeface="+mn-ea"/>
+        <a:cs typeface="+mn-cs"/>
+      </a:defRPr>
+    </a:lvl4pPr>
+    <a:lvl5pPr marL="1828800" algn="l" defTabSz="914400" rtl="0" eaLnBrk="1" latinLnBrk="0" hangingPunct="1">
+      <a:defRPr sz="1200" kern="1200">
+        <a:solidFill>
+          <a:schemeClr val="tx1"/>
+        </a:solidFill>
+        <a:latin typeface="+mn-lt"/>
+        <a:ea typeface="+mn-ea"/>
+        <a:cs typeface="+mn-cs"/>
+      </a:defRPr>
+    </a:lvl5pPr>
+    <a:lvl6pPr marL="2286000" algn="l" defTabSz="914400" rtl="0" eaLnBrk="1" latinLnBrk="0" hangingPunct="1">
+      <a:defRPr sz="1200" kern="1200">
+        <a:solidFill>
+          <a:schemeClr val="tx1"/>
+        </a:solidFill>
+        <a:latin typeface="+mn-lt"/>
+        <a:ea typeface="+mn-ea"/>
+        <a:cs typeface="+mn-cs"/>
+      </a:defRPr>
+    </a:lvl6pPr>
+    <a:lvl7pPr marL="2743200" algn="l" defTabSz="914400" rtl="0" eaLnBrk="1" latinLnBrk="0" hangingPunct="1">
+      <a:defRPr sz="1200" kern="1200">
+        <a:solidFill>
+          <a:schemeClr val="tx1"/>
+        </a:solidFill>
+        <a:latin typeface="+mn-lt"/>
+        <a:ea typeface="+mn-ea"/>
+        <a:cs typeface="+mn-cs"/>
+      </a:defRPr>
+    </a:lvl7pPr>
+    <a:lvl8pPr marL="3200400" algn="l" defTabSz="914400" rtl="0" eaLnBrk="1" latinLnBrk="0" hangingPunct="1">
+      <a:defRPr sz="1200" kern="1200">
+        <a:solidFill>
+          <a:schemeClr val="tx1"/>
+        </a:solidFill>
+        <a:latin typeface="+mn-lt"/>
+        <a:ea typeface="+mn-ea"/>
+        <a:cs typeface="+mn-cs"/>
+      </a:defRPr>
+    </a:lvl8pPr>
+    <a:lvl9pPr marL="3657600" algn="l" defTabSz="914400" rtl="0" eaLnBrk="1" latinLnBrk="0" hangingPunct="1">
+      <a:defRPr sz="1200" kern="1200">
+        <a:solidFill>
+          <a:schemeClr val="tx1"/>
+        </a:solidFill>
+        <a:latin typeface="+mn-lt"/>
+        <a:ea typeface="+mn-ea"/>
+        <a:cs typeface="+mn-cs"/>
+      </a:defRPr>
+    </a:lvl9pPr>
+  </p:notesStyle>
+</p:notesMaster>
+</file>
+
+<file path=ppt/notesSlides/notesSlide1.xml><?xml version="1.0" encoding="utf-8"?>
+<p:notes xmlns:a="http://schemas.openxmlformats.org/drawingml/2006/main" xmlns:r="http://schemas.openxmlformats.org/officeDocument/2006/relationships" xmlns:p="http://schemas.openxmlformats.org/presentationml/2006/main">
+  <p:cSld>
+    <p:spTree>
+      <p:nvGrpSpPr>
+        <p:cNvPr id="1" name=""/>
+        <p:cNvGrpSpPr/>
+        <p:nvPr/>
+      </p:nvGrpSpPr>
+      <p:grpSpPr>
+        <a:xfrm>
+          <a:off x="0" y="0"/>
+          <a:ext cx="0" cy="0"/>
+          <a:chOff x="0" y="0"/>
+          <a:chExt cx="0" cy="0"/>
+        </a:xfrm>
+      </p:grpSpPr>
+      <p:sp>
+        <p:nvSpPr>
+          <p:cNvPr id="2" name="Slide Image Placeholder 1"/>
+          <p:cNvSpPr>
+            <a:spLocks noGrp="1" noRot="1" noChangeAspect="1"/>
+          </p:cNvSpPr>
+          <p:nvPr>
+            <p:ph type="sldImg"/>
+          </p:nvPr>
+        </p:nvSpPr>
+        <p:spPr/>
+      </p:sp>
+      <p:sp>
+        <p:nvSpPr>
+          <p:cNvPr id="3" name="Notes Placeholder 2"/>
+          <p:cNvSpPr>
+            <a:spLocks noGrp="1"/>
+          </p:cNvSpPr>
+          <p:nvPr>
+            <p:ph type="body" idx="1"/>
+          </p:nvPr>
+        </p:nvSpPr>
+        <p:spPr/>
+        <p:txBody>
+          <a:bodyPr/>
+          <a:lstStyle/>
+          <a:p>
+            <a:r>
+              <a:rPr lang="en-CA" dirty="0"/>
+              <a:t>https://www.brainfacts.org/thinking-sensing-and-behaving/touch/2021/the-neurons-responsible-for-making-a-touch-feel-pleasant-111021</a:t>
+            </a:r>
+          </a:p>
+        </p:txBody>
+      </p:sp>
+      <p:sp>
+        <p:nvSpPr>
+          <p:cNvPr id="4" name="Slide Number Placeholder 3"/>
+          <p:cNvSpPr>
+            <a:spLocks noGrp="1"/>
+          </p:cNvSpPr>
+          <p:nvPr>
+            <p:ph type="sldNum" sz="quarter" idx="5"/>
+          </p:nvPr>
+        </p:nvSpPr>
+        <p:spPr/>
+        <p:txBody>
+          <a:bodyPr/>
+          <a:lstStyle/>
+          <a:p>
+            <a:fld id="{D5DFF054-FCE2-473C-BAB8-AEC2ACD15967}" type="slidenum">
+              <a:rPr lang="en-CA" smtClean="0"/>
+              <a:t>2</a:t>
+            </a:fld>
+            <a:endParaRPr lang="en-CA"/>
+          </a:p>
+        </p:txBody>
+      </p:sp>
+    </p:spTree>
+    <p:extLst>
+      <p:ext uri="{BB962C8B-B14F-4D97-AF65-F5344CB8AC3E}">
+        <p14:creationId xmlns:p14="http://schemas.microsoft.com/office/powerpoint/2010/main" val="178662650"/>
+      </p:ext>
+    </p:extLst>
+  </p:cSld>
+  <p:clrMapOvr>
+    <a:masterClrMapping/>
+  </p:clrMapOvr>
+</p:notes>
+</file>
+
+<file path=ppt/notesSlides/notesSlide2.xml><?xml version="1.0" encoding="utf-8"?>
+<p:notes xmlns:a="http://schemas.openxmlformats.org/drawingml/2006/main" xmlns:r="http://schemas.openxmlformats.org/officeDocument/2006/relationships" xmlns:p="http://schemas.openxmlformats.org/presentationml/2006/main">
+  <p:cSld>
+    <p:spTree>
+      <p:nvGrpSpPr>
+        <p:cNvPr id="1" name=""/>
+        <p:cNvGrpSpPr/>
+        <p:nvPr/>
+      </p:nvGrpSpPr>
+      <p:grpSpPr>
+        <a:xfrm>
+          <a:off x="0" y="0"/>
+          <a:ext cx="0" cy="0"/>
+          <a:chOff x="0" y="0"/>
+          <a:chExt cx="0" cy="0"/>
+        </a:xfrm>
+      </p:grpSpPr>
+      <p:sp>
+        <p:nvSpPr>
+          <p:cNvPr id="2" name="Slide Image Placeholder 1"/>
+          <p:cNvSpPr>
+            <a:spLocks noGrp="1" noRot="1" noChangeAspect="1"/>
+          </p:cNvSpPr>
+          <p:nvPr>
+            <p:ph type="sldImg"/>
+          </p:nvPr>
+        </p:nvSpPr>
+        <p:spPr/>
+      </p:sp>
+      <p:sp>
+        <p:nvSpPr>
+          <p:cNvPr id="3" name="Notes Placeholder 2"/>
+          <p:cNvSpPr>
+            <a:spLocks noGrp="1"/>
+          </p:cNvSpPr>
+          <p:nvPr>
+            <p:ph type="body" idx="1"/>
+          </p:nvPr>
+        </p:nvSpPr>
+        <p:spPr/>
+        <p:txBody>
+          <a:bodyPr/>
+          <a:lstStyle/>
+          <a:p>
+            <a:r>
+              <a:rPr lang="en-CA" dirty="0"/>
+              <a:t>https://www.simplypsychedu.com/community/public/posts/492101-an-introduction-to-pain</a:t>
+            </a:r>
+          </a:p>
+        </p:txBody>
+      </p:sp>
+      <p:sp>
+        <p:nvSpPr>
+          <p:cNvPr id="4" name="Slide Number Placeholder 3"/>
+          <p:cNvSpPr>
+            <a:spLocks noGrp="1"/>
+          </p:cNvSpPr>
+          <p:nvPr>
+            <p:ph type="sldNum" sz="quarter" idx="5"/>
+          </p:nvPr>
+        </p:nvSpPr>
+        <p:spPr/>
+        <p:txBody>
+          <a:bodyPr/>
+          <a:lstStyle/>
+          <a:p>
+            <a:fld id="{D5DFF054-FCE2-473C-BAB8-AEC2ACD15967}" type="slidenum">
+              <a:rPr lang="en-CA" smtClean="0"/>
+              <a:t>3</a:t>
+            </a:fld>
+            <a:endParaRPr lang="en-CA"/>
+          </a:p>
+        </p:txBody>
+      </p:sp>
+    </p:spTree>
+    <p:extLst>
+      <p:ext uri="{BB962C8B-B14F-4D97-AF65-F5344CB8AC3E}">
+        <p14:creationId xmlns:p14="http://schemas.microsoft.com/office/powerpoint/2010/main" val="443033035"/>
+      </p:ext>
+    </p:extLst>
+  </p:cSld>
+  <p:clrMapOvr>
+    <a:masterClrMapping/>
+  </p:clrMapOvr>
+</p:notes>
+</file>
+
+<file path=ppt/notesSlides/notesSlide3.xml><?xml version="1.0" encoding="utf-8"?>
+<p:notes xmlns:a="http://schemas.openxmlformats.org/drawingml/2006/main" xmlns:r="http://schemas.openxmlformats.org/officeDocument/2006/relationships" xmlns:p="http://schemas.openxmlformats.org/presentationml/2006/main">
+  <p:cSld>
+    <p:spTree>
+      <p:nvGrpSpPr>
+        <p:cNvPr id="1" name=""/>
+        <p:cNvGrpSpPr/>
+        <p:nvPr/>
+      </p:nvGrpSpPr>
+      <p:grpSpPr>
+        <a:xfrm>
+          <a:off x="0" y="0"/>
+          <a:ext cx="0" cy="0"/>
+          <a:chOff x="0" y="0"/>
+          <a:chExt cx="0" cy="0"/>
+        </a:xfrm>
+      </p:grpSpPr>
+      <p:sp>
+        <p:nvSpPr>
+          <p:cNvPr id="2" name="Slide Image Placeholder 1"/>
+          <p:cNvSpPr>
+            <a:spLocks noGrp="1" noRot="1" noChangeAspect="1"/>
+          </p:cNvSpPr>
+          <p:nvPr>
+            <p:ph type="sldImg"/>
+          </p:nvPr>
+        </p:nvSpPr>
+        <p:spPr/>
+      </p:sp>
+      <p:sp>
+        <p:nvSpPr>
+          <p:cNvPr id="3" name="Notes Placeholder 2"/>
+          <p:cNvSpPr>
+            <a:spLocks noGrp="1"/>
+          </p:cNvSpPr>
+          <p:nvPr>
+            <p:ph type="body" idx="1"/>
+          </p:nvPr>
+        </p:nvSpPr>
+        <p:spPr/>
+        <p:txBody>
+          <a:bodyPr/>
+          <a:lstStyle/>
+          <a:p>
+            <a:r>
+              <a:rPr lang="en-US" sz="1200" b="0" i="0" kern="1200" dirty="0">
+                <a:solidFill>
+                  <a:schemeClr val="tx1"/>
+                </a:solidFill>
+                <a:effectLst/>
+                <a:latin typeface="+mn-lt"/>
+                <a:ea typeface="+mn-ea"/>
+                <a:cs typeface="+mn-cs"/>
+              </a:rPr>
+              <a:t>A-beta fibers, which are mechanoreceptors, do the opposite of C-fibers. A-beta fibers (yellow neuron in the diagram below) synapse on inhibitory interneurons (red neuron in the diagram below) and stimulate them. By stimulating the inhibitory interneurons, the pain signal is reduced. </a:t>
+            </a:r>
+          </a:p>
+          <a:p>
+            <a:endParaRPr lang="en-US" sz="1200" b="0" i="0" kern="1200" dirty="0">
+              <a:solidFill>
+                <a:schemeClr val="tx1"/>
+              </a:solidFill>
+              <a:effectLst/>
+              <a:latin typeface="+mn-lt"/>
+              <a:ea typeface="+mn-ea"/>
+              <a:cs typeface="+mn-cs"/>
+            </a:endParaRPr>
+          </a:p>
+          <a:p>
+            <a:r>
+              <a:rPr lang="en-CA" dirty="0"/>
+              <a:t>https://www.simplypsychedu.com/community/public/posts/492101-an-introduction-to-pain</a:t>
+            </a:r>
+          </a:p>
+        </p:txBody>
+      </p:sp>
+      <p:sp>
+        <p:nvSpPr>
+          <p:cNvPr id="4" name="Slide Number Placeholder 3"/>
+          <p:cNvSpPr>
+            <a:spLocks noGrp="1"/>
+          </p:cNvSpPr>
+          <p:nvPr>
+            <p:ph type="sldNum" sz="quarter" idx="5"/>
+          </p:nvPr>
+        </p:nvSpPr>
+        <p:spPr/>
+        <p:txBody>
+          <a:bodyPr/>
+          <a:lstStyle/>
+          <a:p>
+            <a:fld id="{D5DFF054-FCE2-473C-BAB8-AEC2ACD15967}" type="slidenum">
+              <a:rPr lang="en-CA" smtClean="0"/>
+              <a:t>4</a:t>
+            </a:fld>
+            <a:endParaRPr lang="en-CA"/>
+          </a:p>
+        </p:txBody>
+      </p:sp>
+    </p:spTree>
+    <p:extLst>
+      <p:ext uri="{BB962C8B-B14F-4D97-AF65-F5344CB8AC3E}">
+        <p14:creationId xmlns:p14="http://schemas.microsoft.com/office/powerpoint/2010/main" val="3471627408"/>
+      </p:ext>
+    </p:extLst>
+  </p:cSld>
+  <p:clrMapOvr>
+    <a:masterClrMapping/>
+  </p:clrMapOvr>
+</p:notes>
+</file>
+
+<file path=ppt/notesSlides/notesSlide4.xml><?xml version="1.0" encoding="utf-8"?>
+<p:notes xmlns:a="http://schemas.openxmlformats.org/drawingml/2006/main" xmlns:r="http://schemas.openxmlformats.org/officeDocument/2006/relationships" xmlns:p="http://schemas.openxmlformats.org/presentationml/2006/main">
+  <p:cSld>
+    <p:spTree>
+      <p:nvGrpSpPr>
+        <p:cNvPr id="1" name=""/>
+        <p:cNvGrpSpPr/>
+        <p:nvPr/>
+      </p:nvGrpSpPr>
+      <p:grpSpPr>
+        <a:xfrm>
+          <a:off x="0" y="0"/>
+          <a:ext cx="0" cy="0"/>
+          <a:chOff x="0" y="0"/>
+          <a:chExt cx="0" cy="0"/>
+        </a:xfrm>
+      </p:grpSpPr>
+      <p:sp>
+        <p:nvSpPr>
+          <p:cNvPr id="2" name="Slide Image Placeholder 1"/>
+          <p:cNvSpPr>
+            <a:spLocks noGrp="1" noRot="1" noChangeAspect="1"/>
+          </p:cNvSpPr>
+          <p:nvPr>
+            <p:ph type="sldImg"/>
+          </p:nvPr>
+        </p:nvSpPr>
+        <p:spPr/>
+      </p:sp>
+      <p:sp>
+        <p:nvSpPr>
+          <p:cNvPr id="3" name="Notes Placeholder 2"/>
+          <p:cNvSpPr>
+            <a:spLocks noGrp="1"/>
+          </p:cNvSpPr>
+          <p:nvPr>
+            <p:ph type="body" idx="1"/>
+          </p:nvPr>
+        </p:nvSpPr>
+        <p:spPr/>
+        <p:txBody>
+          <a:bodyPr/>
+          <a:lstStyle/>
+          <a:p>
+            <a:r>
+              <a:rPr lang="en-US" dirty="0"/>
+              <a:t>For touch: current output to be 0.4 </a:t>
+            </a:r>
+            <a:r>
+              <a:rPr lang="en-US" dirty="0" err="1"/>
+              <a:t>nA</a:t>
+            </a:r>
+            <a:endParaRPr lang="en-US" dirty="0"/>
+          </a:p>
+          <a:p>
+            <a:r>
+              <a:rPr lang="en-US" dirty="0"/>
+              <a:t>For pain: current output to be 0.6 </a:t>
+            </a:r>
+            <a:r>
+              <a:rPr lang="en-US" dirty="0" err="1"/>
+              <a:t>nA</a:t>
+            </a:r>
+            <a:endParaRPr lang="en-CA" dirty="0"/>
+          </a:p>
+        </p:txBody>
+      </p:sp>
+      <p:sp>
+        <p:nvSpPr>
+          <p:cNvPr id="4" name="Slide Number Placeholder 3"/>
+          <p:cNvSpPr>
+            <a:spLocks noGrp="1"/>
+          </p:cNvSpPr>
+          <p:nvPr>
+            <p:ph type="sldNum" sz="quarter" idx="5"/>
+          </p:nvPr>
+        </p:nvSpPr>
+        <p:spPr/>
+        <p:txBody>
+          <a:bodyPr/>
+          <a:lstStyle/>
+          <a:p>
+            <a:fld id="{D5DFF054-FCE2-473C-BAB8-AEC2ACD15967}" type="slidenum">
+              <a:rPr lang="en-CA" smtClean="0"/>
+              <a:t>5</a:t>
+            </a:fld>
+            <a:endParaRPr lang="en-CA"/>
+          </a:p>
+        </p:txBody>
+      </p:sp>
+    </p:spTree>
+    <p:extLst>
+      <p:ext uri="{BB962C8B-B14F-4D97-AF65-F5344CB8AC3E}">
+        <p14:creationId xmlns:p14="http://schemas.microsoft.com/office/powerpoint/2010/main" val="21190259"/>
+      </p:ext>
+    </p:extLst>
+  </p:cSld>
+  <p:clrMapOvr>
+    <a:masterClrMapping/>
+  </p:clrMapOvr>
+</p:notes>
+</file>
+
+<file path=ppt/notesSlides/notesSlide5.xml><?xml version="1.0" encoding="utf-8"?>
+<p:notes xmlns:a="http://schemas.openxmlformats.org/drawingml/2006/main" xmlns:r="http://schemas.openxmlformats.org/officeDocument/2006/relationships" xmlns:p="http://schemas.openxmlformats.org/presentationml/2006/main">
+  <p:cSld>
+    <p:spTree>
+      <p:nvGrpSpPr>
+        <p:cNvPr id="1" name=""/>
+        <p:cNvGrpSpPr/>
+        <p:nvPr/>
+      </p:nvGrpSpPr>
+      <p:grpSpPr>
+        <a:xfrm>
+          <a:off x="0" y="0"/>
+          <a:ext cx="0" cy="0"/>
+          <a:chOff x="0" y="0"/>
+          <a:chExt cx="0" cy="0"/>
+        </a:xfrm>
+      </p:grpSpPr>
+      <p:sp>
+        <p:nvSpPr>
+          <p:cNvPr id="2" name="Slide Image Placeholder 1"/>
+          <p:cNvSpPr>
+            <a:spLocks noGrp="1" noRot="1" noChangeAspect="1"/>
+          </p:cNvSpPr>
+          <p:nvPr>
+            <p:ph type="sldImg"/>
+          </p:nvPr>
+        </p:nvSpPr>
+        <p:spPr/>
+      </p:sp>
+      <p:sp>
+        <p:nvSpPr>
+          <p:cNvPr id="3" name="Notes Placeholder 2"/>
+          <p:cNvSpPr>
+            <a:spLocks noGrp="1"/>
+          </p:cNvSpPr>
+          <p:nvPr>
+            <p:ph type="body" idx="1"/>
+          </p:nvPr>
+        </p:nvSpPr>
+        <p:spPr/>
+        <p:txBody>
+          <a:bodyPr/>
+          <a:lstStyle/>
+          <a:p>
+            <a:r>
+              <a:rPr lang="en-US" dirty="0"/>
+              <a:t>Set the pain sensing neuron threshold below -70, around -72</a:t>
+            </a:r>
+            <a:endParaRPr lang="en-CA" dirty="0"/>
+          </a:p>
+        </p:txBody>
+      </p:sp>
+      <p:sp>
+        <p:nvSpPr>
+          <p:cNvPr id="4" name="Slide Number Placeholder 3"/>
+          <p:cNvSpPr>
+            <a:spLocks noGrp="1"/>
+          </p:cNvSpPr>
+          <p:nvPr>
+            <p:ph type="sldNum" sz="quarter" idx="5"/>
+          </p:nvPr>
+        </p:nvSpPr>
+        <p:spPr/>
+        <p:txBody>
+          <a:bodyPr/>
+          <a:lstStyle/>
+          <a:p>
+            <a:fld id="{D5DFF054-FCE2-473C-BAB8-AEC2ACD15967}" type="slidenum">
+              <a:rPr lang="en-CA" smtClean="0"/>
+              <a:t>7</a:t>
+            </a:fld>
+            <a:endParaRPr lang="en-CA"/>
+          </a:p>
+        </p:txBody>
+      </p:sp>
+    </p:spTree>
+    <p:extLst>
+      <p:ext uri="{BB962C8B-B14F-4D97-AF65-F5344CB8AC3E}">
+        <p14:creationId xmlns:p14="http://schemas.microsoft.com/office/powerpoint/2010/main" val="3420607605"/>
+      </p:ext>
+    </p:extLst>
+  </p:cSld>
+  <p:clrMapOvr>
+    <a:masterClrMapping/>
+  </p:clrMapOvr>
+</p:notes>
+</file>
+
+<file path=ppt/notesSlides/notesSlide6.xml><?xml version="1.0" encoding="utf-8"?>
+<p:notes xmlns:a="http://schemas.openxmlformats.org/drawingml/2006/main" xmlns:r="http://schemas.openxmlformats.org/officeDocument/2006/relationships" xmlns:p="http://schemas.openxmlformats.org/presentationml/2006/main">
+  <p:cSld>
+    <p:spTree>
+      <p:nvGrpSpPr>
+        <p:cNvPr id="1" name=""/>
+        <p:cNvGrpSpPr/>
+        <p:nvPr/>
+      </p:nvGrpSpPr>
+      <p:grpSpPr>
+        <a:xfrm>
+          <a:off x="0" y="0"/>
+          <a:ext cx="0" cy="0"/>
+          <a:chOff x="0" y="0"/>
+          <a:chExt cx="0" cy="0"/>
+        </a:xfrm>
+      </p:grpSpPr>
+      <p:sp>
+        <p:nvSpPr>
+          <p:cNvPr id="2" name="Slide Image Placeholder 1"/>
+          <p:cNvSpPr>
+            <a:spLocks noGrp="1" noRot="1" noChangeAspect="1"/>
+          </p:cNvSpPr>
+          <p:nvPr>
+            <p:ph type="sldImg"/>
+          </p:nvPr>
+        </p:nvSpPr>
+        <p:spPr/>
+      </p:sp>
+      <p:sp>
+        <p:nvSpPr>
+          <p:cNvPr id="3" name="Notes Placeholder 2"/>
+          <p:cNvSpPr>
+            <a:spLocks noGrp="1"/>
+          </p:cNvSpPr>
+          <p:nvPr>
+            <p:ph type="body" idx="1"/>
+          </p:nvPr>
+        </p:nvSpPr>
+        <p:spPr/>
+        <p:txBody>
+          <a:bodyPr/>
+          <a:lstStyle/>
+          <a:p>
+            <a:r>
+              <a:rPr lang="en-US" dirty="0"/>
+              <a:t>Set the maximum current to be 5 </a:t>
+            </a:r>
+            <a:r>
+              <a:rPr lang="en-US" dirty="0" err="1"/>
+              <a:t>nA</a:t>
+            </a:r>
+            <a:r>
+              <a:rPr lang="en-US" dirty="0"/>
+              <a:t> and time constant to be 6 </a:t>
+            </a:r>
+            <a:r>
+              <a:rPr lang="en-US" dirty="0" err="1"/>
+              <a:t>ms</a:t>
+            </a:r>
+            <a:endParaRPr lang="en-CA" dirty="0"/>
+          </a:p>
+        </p:txBody>
+      </p:sp>
+      <p:sp>
+        <p:nvSpPr>
+          <p:cNvPr id="4" name="Slide Number Placeholder 3"/>
+          <p:cNvSpPr>
+            <a:spLocks noGrp="1"/>
+          </p:cNvSpPr>
+          <p:nvPr>
+            <p:ph type="sldNum" sz="quarter" idx="5"/>
+          </p:nvPr>
+        </p:nvSpPr>
+        <p:spPr/>
+        <p:txBody>
+          <a:bodyPr/>
+          <a:lstStyle/>
+          <a:p>
+            <a:fld id="{D5DFF054-FCE2-473C-BAB8-AEC2ACD15967}" type="slidenum">
+              <a:rPr lang="en-CA" smtClean="0"/>
+              <a:t>8</a:t>
+            </a:fld>
+            <a:endParaRPr lang="en-CA"/>
+          </a:p>
+        </p:txBody>
+      </p:sp>
+    </p:spTree>
+    <p:extLst>
+      <p:ext uri="{BB962C8B-B14F-4D97-AF65-F5344CB8AC3E}">
+        <p14:creationId xmlns:p14="http://schemas.microsoft.com/office/powerpoint/2010/main" val="1159716083"/>
+      </p:ext>
+    </p:extLst>
+  </p:cSld>
+  <p:clrMapOvr>
+    <a:masterClrMapping/>
+  </p:clrMapOvr>
+</p:notes>
 </file>
 
 <file path=ppt/slideLayouts/slideLayout1.xml><?xml version="1.0" encoding="utf-8"?>
@@ -445,7 +1545,7 @@
           <a:p>
             <a:fld id="{5BAD80E9-4CDB-4189-8047-B8B53E82D14D}" type="datetimeFigureOut">
               <a:rPr lang="en-CA" smtClean="0"/>
-              <a:t>2026-02-15</a:t>
+              <a:t>2026-03-02</a:t>
             </a:fld>
             <a:endParaRPr lang="en-CA"/>
           </a:p>
@@ -645,7 +1745,7 @@
           <a:p>
             <a:fld id="{5BAD80E9-4CDB-4189-8047-B8B53E82D14D}" type="datetimeFigureOut">
               <a:rPr lang="en-CA" smtClean="0"/>
-              <a:t>2026-02-15</a:t>
+              <a:t>2026-03-02</a:t>
             </a:fld>
             <a:endParaRPr lang="en-CA"/>
           </a:p>
@@ -855,7 +1955,7 @@
           <a:p>
             <a:fld id="{5BAD80E9-4CDB-4189-8047-B8B53E82D14D}" type="datetimeFigureOut">
               <a:rPr lang="en-CA" smtClean="0"/>
-              <a:t>2026-02-15</a:t>
+              <a:t>2026-03-02</a:t>
             </a:fld>
             <a:endParaRPr lang="en-CA"/>
           </a:p>
@@ -1055,7 +2155,7 @@
           <a:p>
             <a:fld id="{5BAD80E9-4CDB-4189-8047-B8B53E82D14D}" type="datetimeFigureOut">
               <a:rPr lang="en-CA" smtClean="0"/>
-              <a:t>2026-02-15</a:t>
+              <a:t>2026-03-02</a:t>
             </a:fld>
             <a:endParaRPr lang="en-CA"/>
           </a:p>
@@ -1331,7 +2431,7 @@
           <a:p>
             <a:fld id="{5BAD80E9-4CDB-4189-8047-B8B53E82D14D}" type="datetimeFigureOut">
               <a:rPr lang="en-CA" smtClean="0"/>
-              <a:t>2026-02-15</a:t>
+              <a:t>2026-03-02</a:t>
             </a:fld>
             <a:endParaRPr lang="en-CA"/>
           </a:p>
@@ -1599,7 +2699,7 @@
           <a:p>
             <a:fld id="{5BAD80E9-4CDB-4189-8047-B8B53E82D14D}" type="datetimeFigureOut">
               <a:rPr lang="en-CA" smtClean="0"/>
-              <a:t>2026-02-15</a:t>
+              <a:t>2026-03-02</a:t>
             </a:fld>
             <a:endParaRPr lang="en-CA"/>
           </a:p>
@@ -2014,7 +3114,7 @@
           <a:p>
             <a:fld id="{5BAD80E9-4CDB-4189-8047-B8B53E82D14D}" type="datetimeFigureOut">
               <a:rPr lang="en-CA" smtClean="0"/>
-              <a:t>2026-02-15</a:t>
+              <a:t>2026-03-02</a:t>
             </a:fld>
             <a:endParaRPr lang="en-CA"/>
           </a:p>
@@ -2156,7 +3256,7 @@
           <a:p>
             <a:fld id="{5BAD80E9-4CDB-4189-8047-B8B53E82D14D}" type="datetimeFigureOut">
               <a:rPr lang="en-CA" smtClean="0"/>
-              <a:t>2026-02-15</a:t>
+              <a:t>2026-03-02</a:t>
             </a:fld>
             <a:endParaRPr lang="en-CA"/>
           </a:p>
@@ -2269,7 +3369,7 @@
           <a:p>
             <a:fld id="{5BAD80E9-4CDB-4189-8047-B8B53E82D14D}" type="datetimeFigureOut">
               <a:rPr lang="en-CA" smtClean="0"/>
-              <a:t>2026-02-15</a:t>
+              <a:t>2026-03-02</a:t>
             </a:fld>
             <a:endParaRPr lang="en-CA"/>
           </a:p>
@@ -2582,7 +3682,7 @@
           <a:p>
             <a:fld id="{5BAD80E9-4CDB-4189-8047-B8B53E82D14D}" type="datetimeFigureOut">
               <a:rPr lang="en-CA" smtClean="0"/>
-              <a:t>2026-02-15</a:t>
+              <a:t>2026-03-02</a:t>
             </a:fld>
             <a:endParaRPr lang="en-CA"/>
           </a:p>
@@ -2871,7 +3971,7 @@
           <a:p>
             <a:fld id="{5BAD80E9-4CDB-4189-8047-B8B53E82D14D}" type="datetimeFigureOut">
               <a:rPr lang="en-CA" smtClean="0"/>
-              <a:t>2026-02-15</a:t>
+              <a:t>2026-03-02</a:t>
             </a:fld>
             <a:endParaRPr lang="en-CA"/>
           </a:p>
@@ -3114,7 +4214,7 @@
           <a:p>
             <a:fld id="{5BAD80E9-4CDB-4189-8047-B8B53E82D14D}" type="datetimeFigureOut">
               <a:rPr lang="en-CA" smtClean="0"/>
-              <a:t>2026-02-15</a:t>
+              <a:t>2026-03-02</a:t>
             </a:fld>
             <a:endParaRPr lang="en-CA"/>
           </a:p>
@@ -3581,7 +4681,19 @@
           <a:bodyPr/>
           <a:lstStyle/>
           <a:p>
-            <a:endParaRPr lang="en-CA"/>
+            <a:r>
+              <a:rPr lang="en-US" dirty="0"/>
+              <a:t>Mengyi Xu &amp; </a:t>
+            </a:r>
+            <a:r>
+              <a:rPr lang="en-US" dirty="0" err="1"/>
+              <a:t>Haoyi</a:t>
+            </a:r>
+            <a:r>
+              <a:rPr lang="en-US" dirty="0"/>
+              <a:t> Qiu</a:t>
+            </a:r>
+            <a:endParaRPr lang="en-CA" dirty="0"/>
           </a:p>
         </p:txBody>
       </p:sp>
@@ -3615,12 +4727,37 @@
           <a:chExt cx="0" cy="0"/>
         </a:xfrm>
       </p:grpSpPr>
+      <p:sp>
+        <p:nvSpPr>
+          <p:cNvPr id="2" name="Title 1">
+            <a:extLst>
+              <a:ext uri="{FF2B5EF4-FFF2-40B4-BE49-F238E27FC236}">
+                <a16:creationId xmlns:a16="http://schemas.microsoft.com/office/drawing/2014/main" id="{4022ADA9-9F81-E210-E2CC-5E178F2120C7}"/>
+              </a:ext>
+            </a:extLst>
+          </p:cNvPr>
+          <p:cNvSpPr>
+            <a:spLocks noGrp="1"/>
+          </p:cNvSpPr>
+          <p:nvPr>
+            <p:ph type="title"/>
+          </p:nvPr>
+        </p:nvSpPr>
+        <p:spPr/>
+        <p:txBody>
+          <a:bodyPr/>
+          <a:lstStyle/>
+          <a:p>
+            <a:endParaRPr lang="en-CA"/>
+          </a:p>
+        </p:txBody>
+      </p:sp>
       <p:pic>
         <p:nvPicPr>
-          <p:cNvPr id="7" name="Picture 6">
-            <a:extLst>
-              <a:ext uri="{FF2B5EF4-FFF2-40B4-BE49-F238E27FC236}">
-                <a16:creationId xmlns:a16="http://schemas.microsoft.com/office/drawing/2014/main" id="{C0D55DB6-9321-82D8-7B42-78CB2893B010}"/>
+          <p:cNvPr id="4" name="Picture 3">
+            <a:extLst>
+              <a:ext uri="{FF2B5EF4-FFF2-40B4-BE49-F238E27FC236}">
+                <a16:creationId xmlns:a16="http://schemas.microsoft.com/office/drawing/2014/main" id="{C815FE92-8F83-ADE2-02EA-CC5D32C7A9A0}"/>
               </a:ext>
             </a:extLst>
           </p:cNvPr>
@@ -3630,65 +4767,276 @@
           <p:nvPr/>
         </p:nvPicPr>
         <p:blipFill>
-          <a:blip r:embed="rId2">
-            <a:extLst>
-              <a:ext uri="{28A0092B-C50C-407E-A947-70E740481C1C}">
-                <a14:useLocalDpi xmlns:a14="http://schemas.microsoft.com/office/drawing/2010/main" val="0"/>
-              </a:ext>
-            </a:extLst>
-          </a:blip>
+          <a:blip r:embed="rId3"/>
           <a:stretch>
             <a:fillRect/>
           </a:stretch>
         </p:blipFill>
         <p:spPr>
           <a:xfrm>
-            <a:off x="547687" y="1542910"/>
-            <a:ext cx="11096625" cy="5188033"/>
+            <a:off x="815068" y="1861456"/>
+            <a:ext cx="4661211" cy="4425043"/>
           </a:xfrm>
           <a:prstGeom prst="rect">
             <a:avLst/>
           </a:prstGeom>
         </p:spPr>
       </p:pic>
-      <p:sp>
-        <p:nvSpPr>
-          <p:cNvPr id="8" name="Title 1">
-            <a:extLst>
-              <a:ext uri="{FF2B5EF4-FFF2-40B4-BE49-F238E27FC236}">
-                <a16:creationId xmlns:a16="http://schemas.microsoft.com/office/drawing/2014/main" id="{72999750-86A0-D703-C191-AB3FEBE82680}"/>
-              </a:ext>
-            </a:extLst>
-          </p:cNvPr>
-          <p:cNvSpPr>
-            <a:spLocks noGrp="1"/>
-          </p:cNvSpPr>
-          <p:nvPr>
-            <p:ph type="title"/>
-          </p:nvPr>
-        </p:nvSpPr>
+      <p:pic>
+        <p:nvPicPr>
+          <p:cNvPr id="5" name="Picture 4">
+            <a:extLst>
+              <a:ext uri="{FF2B5EF4-FFF2-40B4-BE49-F238E27FC236}">
+                <a16:creationId xmlns:a16="http://schemas.microsoft.com/office/drawing/2014/main" id="{24778B04-BDD3-EEF3-2AAE-857954E3D6C1}"/>
+              </a:ext>
+            </a:extLst>
+          </p:cNvPr>
+          <p:cNvPicPr>
+            <a:picLocks noChangeAspect="1"/>
+          </p:cNvPicPr>
+          <p:nvPr/>
+        </p:nvPicPr>
+        <p:blipFill>
+          <a:blip r:embed="rId4"/>
+          <a:srcRect l="35811" t="16217" r="5743" b="17118"/>
+          <a:stretch>
+            <a:fillRect/>
+          </a:stretch>
+        </p:blipFill>
         <p:spPr>
           <a:xfrm>
-            <a:off x="838199" y="127057"/>
-            <a:ext cx="10515600" cy="1325563"/>
+            <a:off x="6688975" y="1862209"/>
+            <a:ext cx="3320590" cy="2130552"/>
           </a:xfrm>
+          <a:prstGeom prst="rect">
+            <a:avLst/>
+          </a:prstGeom>
         </p:spPr>
-        <p:txBody>
-          <a:bodyPr/>
-          <a:lstStyle/>
-          <a:p>
+      </p:pic>
+      <p:sp>
+        <p:nvSpPr>
+          <p:cNvPr id="6" name="TextBox 5">
+            <a:extLst>
+              <a:ext uri="{FF2B5EF4-FFF2-40B4-BE49-F238E27FC236}">
+                <a16:creationId xmlns:a16="http://schemas.microsoft.com/office/drawing/2014/main" id="{96E49410-10A4-50BC-6C4D-4FCE704D4034}"/>
+              </a:ext>
+            </a:extLst>
+          </p:cNvPr>
+          <p:cNvSpPr txBox="1"/>
+          <p:nvPr/>
+        </p:nvSpPr>
+        <p:spPr>
+          <a:xfrm>
+            <a:off x="6865680" y="1913154"/>
+            <a:ext cx="1257780" cy="646331"/>
+          </a:xfrm>
+          <a:prstGeom prst="rect">
+            <a:avLst/>
+          </a:prstGeom>
+          <a:noFill/>
+        </p:spPr>
+        <p:txBody>
+          <a:bodyPr wrap="none" rtlCol="0">
+            <a:spAutoFit/>
+          </a:bodyPr>
+          <a:lstStyle/>
+          <a:p>
+            <a:pPr algn="ctr"/>
             <a:r>
               <a:rPr lang="en-US" dirty="0"/>
-              <a:t>Low input -&gt; touch &amp; high input -&gt; pain</a:t>
+              <a:t>A</a:t>
+            </a:r>
+            <a:r>
+              <a:rPr lang="el-GR" dirty="0"/>
+              <a:t>β</a:t>
+            </a:r>
+            <a:r>
+              <a:rPr lang="en-US" dirty="0"/>
+              <a:t> – Fibers</a:t>
+            </a:r>
+          </a:p>
+          <a:p>
+            <a:pPr algn="ctr"/>
+            <a:r>
+              <a:rPr lang="en-US" dirty="0"/>
+              <a:t>Touch</a:t>
             </a:r>
             <a:endParaRPr lang="en-CA" dirty="0"/>
           </a:p>
         </p:txBody>
       </p:sp>
+      <p:pic>
+        <p:nvPicPr>
+          <p:cNvPr id="7" name="Picture 6">
+            <a:extLst>
+              <a:ext uri="{FF2B5EF4-FFF2-40B4-BE49-F238E27FC236}">
+                <a16:creationId xmlns:a16="http://schemas.microsoft.com/office/drawing/2014/main" id="{CAE98254-4312-6727-185B-50E76B9D305D}"/>
+              </a:ext>
+            </a:extLst>
+          </p:cNvPr>
+          <p:cNvPicPr>
+            <a:picLocks noChangeAspect="1"/>
+          </p:cNvPicPr>
+          <p:nvPr/>
+        </p:nvPicPr>
+        <p:blipFill>
+          <a:blip r:embed="rId5"/>
+          <a:srcRect l="46902" t="20381" r="34332" b="56420"/>
+          <a:stretch>
+            <a:fillRect/>
+          </a:stretch>
+        </p:blipFill>
+        <p:spPr>
+          <a:xfrm>
+            <a:off x="6727370" y="4122280"/>
+            <a:ext cx="3292383" cy="2289405"/>
+          </a:xfrm>
+          <a:prstGeom prst="rect">
+            <a:avLst/>
+          </a:prstGeom>
+        </p:spPr>
+      </p:pic>
+      <p:sp>
+        <p:nvSpPr>
+          <p:cNvPr id="8" name="TextBox 7">
+            <a:extLst>
+              <a:ext uri="{FF2B5EF4-FFF2-40B4-BE49-F238E27FC236}">
+                <a16:creationId xmlns:a16="http://schemas.microsoft.com/office/drawing/2014/main" id="{993A12EB-B634-5603-6B34-63E74BE1EACE}"/>
+              </a:ext>
+            </a:extLst>
+          </p:cNvPr>
+          <p:cNvSpPr txBox="1"/>
+          <p:nvPr/>
+        </p:nvSpPr>
+        <p:spPr>
+          <a:xfrm>
+            <a:off x="6879335" y="4206242"/>
+            <a:ext cx="1155188" cy="646331"/>
+          </a:xfrm>
+          <a:prstGeom prst="rect">
+            <a:avLst/>
+          </a:prstGeom>
+          <a:noFill/>
+        </p:spPr>
+        <p:txBody>
+          <a:bodyPr wrap="none" rtlCol="0">
+            <a:spAutoFit/>
+          </a:bodyPr>
+          <a:lstStyle/>
+          <a:p>
+            <a:pPr algn="ctr"/>
+            <a:r>
+              <a:rPr lang="en-US" dirty="0"/>
+              <a:t>C – Fibers</a:t>
+            </a:r>
+          </a:p>
+          <a:p>
+            <a:pPr algn="ctr"/>
+            <a:r>
+              <a:rPr lang="en-US" dirty="0"/>
+              <a:t>Pain</a:t>
+            </a:r>
+            <a:endParaRPr lang="en-CA" dirty="0"/>
+          </a:p>
+        </p:txBody>
+      </p:sp>
+      <p:sp>
+        <p:nvSpPr>
+          <p:cNvPr id="9" name="Oval 8">
+            <a:extLst>
+              <a:ext uri="{FF2B5EF4-FFF2-40B4-BE49-F238E27FC236}">
+                <a16:creationId xmlns:a16="http://schemas.microsoft.com/office/drawing/2014/main" id="{1725C76B-5B8A-CBFF-C1F8-57A87E99BE2F}"/>
+              </a:ext>
+            </a:extLst>
+          </p:cNvPr>
+          <p:cNvSpPr/>
+          <p:nvPr/>
+        </p:nvSpPr>
+        <p:spPr>
+          <a:xfrm>
+            <a:off x="5627914" y="1393371"/>
+            <a:ext cx="5595257" cy="5464629"/>
+          </a:xfrm>
+          <a:prstGeom prst="ellipse">
+            <a:avLst/>
+          </a:prstGeom>
+          <a:noFill/>
+          <a:ln w="57150">
+            <a:solidFill>
+              <a:srgbClr val="002060"/>
+            </a:solidFill>
+          </a:ln>
+        </p:spPr>
+        <p:style>
+          <a:lnRef idx="2">
+            <a:schemeClr val="accent1">
+              <a:shade val="15000"/>
+            </a:schemeClr>
+          </a:lnRef>
+          <a:fillRef idx="1">
+            <a:schemeClr val="accent1"/>
+          </a:fillRef>
+          <a:effectRef idx="0">
+            <a:schemeClr val="accent1"/>
+          </a:effectRef>
+          <a:fontRef idx="minor">
+            <a:schemeClr val="lt1"/>
+          </a:fontRef>
+        </p:style>
+        <p:txBody>
+          <a:bodyPr rtlCol="0" anchor="ctr"/>
+          <a:lstStyle/>
+          <a:p>
+            <a:pPr algn="ctr"/>
+            <a:endParaRPr lang="en-CA"/>
+          </a:p>
+        </p:txBody>
+      </p:sp>
+      <p:cxnSp>
+        <p:nvCxnSpPr>
+          <p:cNvPr id="13" name="Straight Arrow Connector 12">
+            <a:extLst>
+              <a:ext uri="{FF2B5EF4-FFF2-40B4-BE49-F238E27FC236}">
+                <a16:creationId xmlns:a16="http://schemas.microsoft.com/office/drawing/2014/main" id="{CB360A81-42D5-6E03-ED66-5952EA497D3D}"/>
+              </a:ext>
+            </a:extLst>
+          </p:cNvPr>
+          <p:cNvCxnSpPr>
+            <a:cxnSpLocks/>
+          </p:cNvCxnSpPr>
+          <p:nvPr/>
+        </p:nvCxnSpPr>
+        <p:spPr>
+          <a:xfrm flipV="1">
+            <a:off x="3483429" y="3483429"/>
+            <a:ext cx="2177142" cy="957942"/>
+          </a:xfrm>
+          <a:prstGeom prst="straightConnector1">
+            <a:avLst/>
+          </a:prstGeom>
+          <a:ln w="57150">
+            <a:tailEnd type="triangle"/>
+          </a:ln>
+        </p:spPr>
+        <p:style>
+          <a:lnRef idx="2">
+            <a:schemeClr val="accent1"/>
+          </a:lnRef>
+          <a:fillRef idx="0">
+            <a:schemeClr val="accent1"/>
+          </a:fillRef>
+          <a:effectRef idx="1">
+            <a:schemeClr val="accent1"/>
+          </a:effectRef>
+          <a:fontRef idx="minor">
+            <a:schemeClr val="tx1"/>
+          </a:fontRef>
+        </p:style>
+      </p:cxnSp>
     </p:spTree>
     <p:extLst>
       <p:ext uri="{BB962C8B-B14F-4D97-AF65-F5344CB8AC3E}">
-        <p14:creationId xmlns:p14="http://schemas.microsoft.com/office/powerpoint/2010/main" val="3098464200"/>
+        <p14:creationId xmlns:p14="http://schemas.microsoft.com/office/powerpoint/2010/main" val="140896304"/>
       </p:ext>
     </p:extLst>
   </p:cSld>
@@ -3715,80 +5063,82 @@
           <a:chExt cx="0" cy="0"/>
         </a:xfrm>
       </p:grpSpPr>
+      <p:sp>
+        <p:nvSpPr>
+          <p:cNvPr id="2" name="Title 1">
+            <a:extLst>
+              <a:ext uri="{FF2B5EF4-FFF2-40B4-BE49-F238E27FC236}">
+                <a16:creationId xmlns:a16="http://schemas.microsoft.com/office/drawing/2014/main" id="{61A29D82-B254-7722-F7C6-AE9F3D4DCB2A}"/>
+              </a:ext>
+            </a:extLst>
+          </p:cNvPr>
+          <p:cNvSpPr>
+            <a:spLocks noGrp="1"/>
+          </p:cNvSpPr>
+          <p:nvPr>
+            <p:ph type="title"/>
+          </p:nvPr>
+        </p:nvSpPr>
+        <p:spPr/>
+        <p:txBody>
+          <a:bodyPr/>
+          <a:lstStyle/>
+          <a:p>
+            <a:endParaRPr lang="en-CA"/>
+          </a:p>
+        </p:txBody>
+      </p:sp>
       <p:pic>
         <p:nvPicPr>
-          <p:cNvPr id="5" name="Picture 4">
-            <a:extLst>
-              <a:ext uri="{FF2B5EF4-FFF2-40B4-BE49-F238E27FC236}">
-                <a16:creationId xmlns:a16="http://schemas.microsoft.com/office/drawing/2014/main" id="{4E089CB5-CC65-819A-D5E9-1A0719C8A112}"/>
+          <p:cNvPr id="1026" name="Picture 2">
+            <a:extLst>
+              <a:ext uri="{FF2B5EF4-FFF2-40B4-BE49-F238E27FC236}">
+                <a16:creationId xmlns:a16="http://schemas.microsoft.com/office/drawing/2014/main" id="{5330B226-CC8A-6DD5-AD9C-61D5FFB7F4FF}"/>
               </a:ext>
             </a:extLst>
           </p:cNvPr>
           <p:cNvPicPr>
-            <a:picLocks noChangeAspect="1"/>
+            <a:picLocks noChangeAspect="1" noChangeArrowheads="1"/>
           </p:cNvPicPr>
           <p:nvPr/>
         </p:nvPicPr>
         <p:blipFill>
-          <a:blip r:embed="rId2">
+          <a:blip r:embed="rId3">
             <a:extLst>
               <a:ext uri="{28A0092B-C50C-407E-A947-70E740481C1C}">
                 <a14:useLocalDpi xmlns:a14="http://schemas.microsoft.com/office/drawing/2010/main" val="0"/>
               </a:ext>
             </a:extLst>
           </a:blip>
+          <a:srcRect/>
           <a:stretch>
             <a:fillRect/>
           </a:stretch>
         </p:blipFill>
-        <p:spPr>
+        <p:spPr bwMode="auto">
           <a:xfrm>
-            <a:off x="685008" y="1722500"/>
-            <a:ext cx="10991879" cy="5046825"/>
+            <a:off x="2177796" y="1899920"/>
+            <a:ext cx="7094220" cy="4729480"/>
           </a:xfrm>
           <a:prstGeom prst="rect">
             <a:avLst/>
           </a:prstGeom>
+          <a:noFill/>
+          <a:extLst>
+            <a:ext uri="{909E8E84-426E-40DD-AFC4-6F175D3DCCD1}">
+              <a14:hiddenFill xmlns:a14="http://schemas.microsoft.com/office/drawing/2010/main">
+                <a:solidFill>
+                  <a:srgbClr val="FFFFFF"/>
+                </a:solidFill>
+              </a14:hiddenFill>
+            </a:ext>
+          </a:extLst>
         </p:spPr>
       </p:pic>
-      <p:sp>
-        <p:nvSpPr>
-          <p:cNvPr id="6" name="Title 1">
-            <a:extLst>
-              <a:ext uri="{FF2B5EF4-FFF2-40B4-BE49-F238E27FC236}">
-                <a16:creationId xmlns:a16="http://schemas.microsoft.com/office/drawing/2014/main" id="{0338C292-DA98-4E97-69FF-BF435BC89E9D}"/>
-              </a:ext>
-            </a:extLst>
-          </p:cNvPr>
-          <p:cNvSpPr>
-            <a:spLocks noGrp="1"/>
-          </p:cNvSpPr>
-          <p:nvPr>
-            <p:ph type="title"/>
-          </p:nvPr>
-        </p:nvSpPr>
-        <p:spPr>
-          <a:xfrm>
-            <a:off x="838199" y="127057"/>
-            <a:ext cx="10515600" cy="1325563"/>
-          </a:xfrm>
-        </p:spPr>
-        <p:txBody>
-          <a:bodyPr/>
-          <a:lstStyle/>
-          <a:p>
-            <a:r>
-              <a:rPr lang="en-US" dirty="0"/>
-              <a:t>Touch relief pain</a:t>
-            </a:r>
-            <a:endParaRPr lang="en-CA" dirty="0"/>
-          </a:p>
-        </p:txBody>
-      </p:sp>
     </p:spTree>
     <p:extLst>
       <p:ext uri="{BB962C8B-B14F-4D97-AF65-F5344CB8AC3E}">
-        <p14:creationId xmlns:p14="http://schemas.microsoft.com/office/powerpoint/2010/main" val="2928508640"/>
+        <p14:creationId xmlns:p14="http://schemas.microsoft.com/office/powerpoint/2010/main" val="4089420750"/>
       </p:ext>
     </p:extLst>
   </p:cSld>
@@ -3815,12 +5165,37 @@
           <a:chExt cx="0" cy="0"/>
         </a:xfrm>
       </p:grpSpPr>
+      <p:sp>
+        <p:nvSpPr>
+          <p:cNvPr id="2" name="Title 1">
+            <a:extLst>
+              <a:ext uri="{FF2B5EF4-FFF2-40B4-BE49-F238E27FC236}">
+                <a16:creationId xmlns:a16="http://schemas.microsoft.com/office/drawing/2014/main" id="{3CA1AE54-10E1-9962-FB46-EFBA321D215C}"/>
+              </a:ext>
+            </a:extLst>
+          </p:cNvPr>
+          <p:cNvSpPr>
+            <a:spLocks noGrp="1"/>
+          </p:cNvSpPr>
+          <p:nvPr>
+            <p:ph type="title"/>
+          </p:nvPr>
+        </p:nvSpPr>
+        <p:spPr/>
+        <p:txBody>
+          <a:bodyPr/>
+          <a:lstStyle/>
+          <a:p>
+            <a:endParaRPr lang="en-CA"/>
+          </a:p>
+        </p:txBody>
+      </p:sp>
       <p:pic>
         <p:nvPicPr>
-          <p:cNvPr id="5" name="Picture 4">
-            <a:extLst>
-              <a:ext uri="{FF2B5EF4-FFF2-40B4-BE49-F238E27FC236}">
-                <a16:creationId xmlns:a16="http://schemas.microsoft.com/office/drawing/2014/main" id="{C2A35471-10ED-349E-1910-DED5ADDF4773}"/>
+          <p:cNvPr id="4" name="Picture 3">
+            <a:extLst>
+              <a:ext uri="{FF2B5EF4-FFF2-40B4-BE49-F238E27FC236}">
+                <a16:creationId xmlns:a16="http://schemas.microsoft.com/office/drawing/2014/main" id="{AFF61227-20CE-0F4D-53E4-4EE0E60DFAE6}"/>
               </a:ext>
             </a:extLst>
           </p:cNvPr>
@@ -3830,65 +5205,25 @@
           <p:nvPr/>
         </p:nvPicPr>
         <p:blipFill>
-          <a:blip r:embed="rId2">
-            <a:extLst>
-              <a:ext uri="{28A0092B-C50C-407E-A947-70E740481C1C}">
-                <a14:useLocalDpi xmlns:a14="http://schemas.microsoft.com/office/drawing/2010/main" val="0"/>
-              </a:ext>
-            </a:extLst>
-          </a:blip>
+          <a:blip r:embed="rId3"/>
           <a:stretch>
             <a:fillRect/>
           </a:stretch>
         </p:blipFill>
         <p:spPr>
           <a:xfrm>
-            <a:off x="485775" y="1128696"/>
-            <a:ext cx="11220450" cy="5055911"/>
+            <a:off x="2171700" y="1817914"/>
+            <a:ext cx="7560129" cy="5040086"/>
           </a:xfrm>
           <a:prstGeom prst="rect">
             <a:avLst/>
           </a:prstGeom>
         </p:spPr>
       </p:pic>
-      <p:sp>
-        <p:nvSpPr>
-          <p:cNvPr id="6" name="Title 1">
-            <a:extLst>
-              <a:ext uri="{FF2B5EF4-FFF2-40B4-BE49-F238E27FC236}">
-                <a16:creationId xmlns:a16="http://schemas.microsoft.com/office/drawing/2014/main" id="{D873D1B9-8292-22D5-A573-6B66C70E5804}"/>
-              </a:ext>
-            </a:extLst>
-          </p:cNvPr>
-          <p:cNvSpPr>
-            <a:spLocks noGrp="1"/>
-          </p:cNvSpPr>
-          <p:nvPr>
-            <p:ph type="title"/>
-          </p:nvPr>
-        </p:nvSpPr>
-        <p:spPr>
-          <a:xfrm>
-            <a:off x="838199" y="127057"/>
-            <a:ext cx="10515600" cy="1325563"/>
-          </a:xfrm>
-        </p:spPr>
-        <p:txBody>
-          <a:bodyPr/>
-          <a:lstStyle/>
-          <a:p>
-            <a:r>
-              <a:rPr lang="en-US" dirty="0"/>
-              <a:t>Chronic pain: pain threshold decreases</a:t>
-            </a:r>
-            <a:endParaRPr lang="en-CA" dirty="0"/>
-          </a:p>
-        </p:txBody>
-      </p:sp>
     </p:spTree>
     <p:extLst>
       <p:ext uri="{BB962C8B-B14F-4D97-AF65-F5344CB8AC3E}">
-        <p14:creationId xmlns:p14="http://schemas.microsoft.com/office/powerpoint/2010/main" val="3671709465"/>
+        <p14:creationId xmlns:p14="http://schemas.microsoft.com/office/powerpoint/2010/main" val="1346584351"/>
       </p:ext>
     </p:extLst>
   </p:cSld>
@@ -3917,10 +5252,110 @@
       </p:grpSpPr>
       <p:pic>
         <p:nvPicPr>
+          <p:cNvPr id="7" name="Picture 6">
+            <a:extLst>
+              <a:ext uri="{FF2B5EF4-FFF2-40B4-BE49-F238E27FC236}">
+                <a16:creationId xmlns:a16="http://schemas.microsoft.com/office/drawing/2014/main" id="{C0D55DB6-9321-82D8-7B42-78CB2893B010}"/>
+              </a:ext>
+            </a:extLst>
+          </p:cNvPr>
+          <p:cNvPicPr>
+            <a:picLocks noChangeAspect="1"/>
+          </p:cNvPicPr>
+          <p:nvPr/>
+        </p:nvPicPr>
+        <p:blipFill>
+          <a:blip r:embed="rId3">
+            <a:extLst>
+              <a:ext uri="{28A0092B-C50C-407E-A947-70E740481C1C}">
+                <a14:useLocalDpi xmlns:a14="http://schemas.microsoft.com/office/drawing/2010/main" val="0"/>
+              </a:ext>
+            </a:extLst>
+          </a:blip>
+          <a:stretch>
+            <a:fillRect/>
+          </a:stretch>
+        </p:blipFill>
+        <p:spPr>
+          <a:xfrm>
+            <a:off x="547687" y="1542910"/>
+            <a:ext cx="11096625" cy="5188033"/>
+          </a:xfrm>
+          <a:prstGeom prst="rect">
+            <a:avLst/>
+          </a:prstGeom>
+        </p:spPr>
+      </p:pic>
+      <p:sp>
+        <p:nvSpPr>
+          <p:cNvPr id="8" name="Title 1">
+            <a:extLst>
+              <a:ext uri="{FF2B5EF4-FFF2-40B4-BE49-F238E27FC236}">
+                <a16:creationId xmlns:a16="http://schemas.microsoft.com/office/drawing/2014/main" id="{72999750-86A0-D703-C191-AB3FEBE82680}"/>
+              </a:ext>
+            </a:extLst>
+          </p:cNvPr>
+          <p:cNvSpPr>
+            <a:spLocks noGrp="1"/>
+          </p:cNvSpPr>
+          <p:nvPr>
+            <p:ph type="title"/>
+          </p:nvPr>
+        </p:nvSpPr>
+        <p:spPr>
+          <a:xfrm>
+            <a:off x="838199" y="127057"/>
+            <a:ext cx="10515600" cy="1325563"/>
+          </a:xfrm>
+        </p:spPr>
+        <p:txBody>
+          <a:bodyPr/>
+          <a:lstStyle/>
+          <a:p>
+            <a:r>
+              <a:rPr lang="en-US" dirty="0"/>
+              <a:t>Low input -&gt; touch &amp; high input -&gt; pain</a:t>
+            </a:r>
+            <a:endParaRPr lang="en-CA" dirty="0"/>
+          </a:p>
+        </p:txBody>
+      </p:sp>
+    </p:spTree>
+    <p:extLst>
+      <p:ext uri="{BB962C8B-B14F-4D97-AF65-F5344CB8AC3E}">
+        <p14:creationId xmlns:p14="http://schemas.microsoft.com/office/powerpoint/2010/main" val="3098464200"/>
+      </p:ext>
+    </p:extLst>
+  </p:cSld>
+  <p:clrMapOvr>
+    <a:masterClrMapping/>
+  </p:clrMapOvr>
+</p:sld>
+</file>
+
+<file path=ppt/slides/slide6.xml><?xml version="1.0" encoding="utf-8"?>
+<p:sld xmlns:a="http://schemas.openxmlformats.org/drawingml/2006/main" xmlns:r="http://schemas.openxmlformats.org/officeDocument/2006/relationships" xmlns:p="http://schemas.openxmlformats.org/presentationml/2006/main">
+  <p:cSld>
+    <p:spTree>
+      <p:nvGrpSpPr>
+        <p:cNvPr id="1" name=""/>
+        <p:cNvGrpSpPr/>
+        <p:nvPr/>
+      </p:nvGrpSpPr>
+      <p:grpSpPr>
+        <a:xfrm>
+          <a:off x="0" y="0"/>
+          <a:ext cx="0" cy="0"/>
+          <a:chOff x="0" y="0"/>
+          <a:chExt cx="0" cy="0"/>
+        </a:xfrm>
+      </p:grpSpPr>
+      <p:pic>
+        <p:nvPicPr>
           <p:cNvPr id="5" name="Picture 4">
             <a:extLst>
               <a:ext uri="{FF2B5EF4-FFF2-40B4-BE49-F238E27FC236}">
-                <a16:creationId xmlns:a16="http://schemas.microsoft.com/office/drawing/2014/main" id="{5CE5D14F-C34A-0E56-5AB9-C48778C4D306}"/>
+                <a16:creationId xmlns:a16="http://schemas.microsoft.com/office/drawing/2014/main" id="{4E089CB5-CC65-819A-D5E9-1A0719C8A112}"/>
               </a:ext>
             </a:extLst>
           </p:cNvPr>
@@ -3931,6 +5366,206 @@
         </p:nvPicPr>
         <p:blipFill>
           <a:blip r:embed="rId2">
+            <a:extLst>
+              <a:ext uri="{28A0092B-C50C-407E-A947-70E740481C1C}">
+                <a14:useLocalDpi xmlns:a14="http://schemas.microsoft.com/office/drawing/2010/main" val="0"/>
+              </a:ext>
+            </a:extLst>
+          </a:blip>
+          <a:stretch>
+            <a:fillRect/>
+          </a:stretch>
+        </p:blipFill>
+        <p:spPr>
+          <a:xfrm>
+            <a:off x="685008" y="1722500"/>
+            <a:ext cx="10991879" cy="5046825"/>
+          </a:xfrm>
+          <a:prstGeom prst="rect">
+            <a:avLst/>
+          </a:prstGeom>
+        </p:spPr>
+      </p:pic>
+      <p:sp>
+        <p:nvSpPr>
+          <p:cNvPr id="6" name="Title 1">
+            <a:extLst>
+              <a:ext uri="{FF2B5EF4-FFF2-40B4-BE49-F238E27FC236}">
+                <a16:creationId xmlns:a16="http://schemas.microsoft.com/office/drawing/2014/main" id="{0338C292-DA98-4E97-69FF-BF435BC89E9D}"/>
+              </a:ext>
+            </a:extLst>
+          </p:cNvPr>
+          <p:cNvSpPr>
+            <a:spLocks noGrp="1"/>
+          </p:cNvSpPr>
+          <p:nvPr>
+            <p:ph type="title"/>
+          </p:nvPr>
+        </p:nvSpPr>
+        <p:spPr>
+          <a:xfrm>
+            <a:off x="838199" y="127057"/>
+            <a:ext cx="10515600" cy="1325563"/>
+          </a:xfrm>
+        </p:spPr>
+        <p:txBody>
+          <a:bodyPr/>
+          <a:lstStyle/>
+          <a:p>
+            <a:r>
+              <a:rPr lang="en-US" dirty="0"/>
+              <a:t>Touch relief pain</a:t>
+            </a:r>
+            <a:endParaRPr lang="en-CA" dirty="0"/>
+          </a:p>
+        </p:txBody>
+      </p:sp>
+    </p:spTree>
+    <p:extLst>
+      <p:ext uri="{BB962C8B-B14F-4D97-AF65-F5344CB8AC3E}">
+        <p14:creationId xmlns:p14="http://schemas.microsoft.com/office/powerpoint/2010/main" val="2928508640"/>
+      </p:ext>
+    </p:extLst>
+  </p:cSld>
+  <p:clrMapOvr>
+    <a:masterClrMapping/>
+  </p:clrMapOvr>
+</p:sld>
+</file>
+
+<file path=ppt/slides/slide7.xml><?xml version="1.0" encoding="utf-8"?>
+<p:sld xmlns:a="http://schemas.openxmlformats.org/drawingml/2006/main" xmlns:r="http://schemas.openxmlformats.org/officeDocument/2006/relationships" xmlns:p="http://schemas.openxmlformats.org/presentationml/2006/main">
+  <p:cSld>
+    <p:spTree>
+      <p:nvGrpSpPr>
+        <p:cNvPr id="1" name=""/>
+        <p:cNvGrpSpPr/>
+        <p:nvPr/>
+      </p:nvGrpSpPr>
+      <p:grpSpPr>
+        <a:xfrm>
+          <a:off x="0" y="0"/>
+          <a:ext cx="0" cy="0"/>
+          <a:chOff x="0" y="0"/>
+          <a:chExt cx="0" cy="0"/>
+        </a:xfrm>
+      </p:grpSpPr>
+      <p:pic>
+        <p:nvPicPr>
+          <p:cNvPr id="5" name="Picture 4">
+            <a:extLst>
+              <a:ext uri="{FF2B5EF4-FFF2-40B4-BE49-F238E27FC236}">
+                <a16:creationId xmlns:a16="http://schemas.microsoft.com/office/drawing/2014/main" id="{C2A35471-10ED-349E-1910-DED5ADDF4773}"/>
+              </a:ext>
+            </a:extLst>
+          </p:cNvPr>
+          <p:cNvPicPr>
+            <a:picLocks noChangeAspect="1"/>
+          </p:cNvPicPr>
+          <p:nvPr/>
+        </p:nvPicPr>
+        <p:blipFill>
+          <a:blip r:embed="rId3">
+            <a:extLst>
+              <a:ext uri="{28A0092B-C50C-407E-A947-70E740481C1C}">
+                <a14:useLocalDpi xmlns:a14="http://schemas.microsoft.com/office/drawing/2010/main" val="0"/>
+              </a:ext>
+            </a:extLst>
+          </a:blip>
+          <a:stretch>
+            <a:fillRect/>
+          </a:stretch>
+        </p:blipFill>
+        <p:spPr>
+          <a:xfrm>
+            <a:off x="485775" y="1128696"/>
+            <a:ext cx="11220450" cy="5055911"/>
+          </a:xfrm>
+          <a:prstGeom prst="rect">
+            <a:avLst/>
+          </a:prstGeom>
+        </p:spPr>
+      </p:pic>
+      <p:sp>
+        <p:nvSpPr>
+          <p:cNvPr id="6" name="Title 1">
+            <a:extLst>
+              <a:ext uri="{FF2B5EF4-FFF2-40B4-BE49-F238E27FC236}">
+                <a16:creationId xmlns:a16="http://schemas.microsoft.com/office/drawing/2014/main" id="{D873D1B9-8292-22D5-A573-6B66C70E5804}"/>
+              </a:ext>
+            </a:extLst>
+          </p:cNvPr>
+          <p:cNvSpPr>
+            <a:spLocks noGrp="1"/>
+          </p:cNvSpPr>
+          <p:nvPr>
+            <p:ph type="title"/>
+          </p:nvPr>
+        </p:nvSpPr>
+        <p:spPr>
+          <a:xfrm>
+            <a:off x="838199" y="127057"/>
+            <a:ext cx="10515600" cy="1325563"/>
+          </a:xfrm>
+        </p:spPr>
+        <p:txBody>
+          <a:bodyPr/>
+          <a:lstStyle/>
+          <a:p>
+            <a:r>
+              <a:rPr lang="en-US" dirty="0"/>
+              <a:t>Chronic pain: pain threshold decreases</a:t>
+            </a:r>
+            <a:endParaRPr lang="en-CA" dirty="0"/>
+          </a:p>
+        </p:txBody>
+      </p:sp>
+    </p:spTree>
+    <p:extLst>
+      <p:ext uri="{BB962C8B-B14F-4D97-AF65-F5344CB8AC3E}">
+        <p14:creationId xmlns:p14="http://schemas.microsoft.com/office/powerpoint/2010/main" val="3671709465"/>
+      </p:ext>
+    </p:extLst>
+  </p:cSld>
+  <p:clrMapOvr>
+    <a:masterClrMapping/>
+  </p:clrMapOvr>
+</p:sld>
+</file>
+
+<file path=ppt/slides/slide8.xml><?xml version="1.0" encoding="utf-8"?>
+<p:sld xmlns:a="http://schemas.openxmlformats.org/drawingml/2006/main" xmlns:r="http://schemas.openxmlformats.org/officeDocument/2006/relationships" xmlns:p="http://schemas.openxmlformats.org/presentationml/2006/main">
+  <p:cSld>
+    <p:spTree>
+      <p:nvGrpSpPr>
+        <p:cNvPr id="1" name=""/>
+        <p:cNvGrpSpPr/>
+        <p:nvPr/>
+      </p:nvGrpSpPr>
+      <p:grpSpPr>
+        <a:xfrm>
+          <a:off x="0" y="0"/>
+          <a:ext cx="0" cy="0"/>
+          <a:chOff x="0" y="0"/>
+          <a:chExt cx="0" cy="0"/>
+        </a:xfrm>
+      </p:grpSpPr>
+      <p:pic>
+        <p:nvPicPr>
+          <p:cNvPr id="5" name="Picture 4">
+            <a:extLst>
+              <a:ext uri="{FF2B5EF4-FFF2-40B4-BE49-F238E27FC236}">
+                <a16:creationId xmlns:a16="http://schemas.microsoft.com/office/drawing/2014/main" id="{5CE5D14F-C34A-0E56-5AB9-C48778C4D306}"/>
+              </a:ext>
+            </a:extLst>
+          </p:cNvPr>
+          <p:cNvPicPr>
+            <a:picLocks noChangeAspect="1"/>
+          </p:cNvPicPr>
+          <p:nvPr/>
+        </p:nvPicPr>
+        <p:blipFill>
+          <a:blip r:embed="rId3">
             <a:extLst>
               <a:ext uri="{28A0092B-C50C-407E-A947-70E740481C1C}">
                 <a14:useLocalDpi xmlns:a14="http://schemas.microsoft.com/office/drawing/2010/main" val="0"/>
@@ -4313,7 +5948,339 @@
 </a:theme>
 </file>
 
+<file path=ppt/theme/theme2.xml><?xml version="1.0" encoding="utf-8"?>
+<a:theme xmlns:a="http://schemas.openxmlformats.org/drawingml/2006/main" name="Office Theme">
+  <a:themeElements>
+    <a:clrScheme name="Office">
+      <a:dk1>
+        <a:sysClr val="windowText" lastClr="000000"/>
+      </a:dk1>
+      <a:lt1>
+        <a:sysClr val="window" lastClr="FFFFFF"/>
+      </a:lt1>
+      <a:dk2>
+        <a:srgbClr val="0E2841"/>
+      </a:dk2>
+      <a:lt2>
+        <a:srgbClr val="E8E8E8"/>
+      </a:lt2>
+      <a:accent1>
+        <a:srgbClr val="156082"/>
+      </a:accent1>
+      <a:accent2>
+        <a:srgbClr val="E97132"/>
+      </a:accent2>
+      <a:accent3>
+        <a:srgbClr val="196B24"/>
+      </a:accent3>
+      <a:accent4>
+        <a:srgbClr val="0F9ED5"/>
+      </a:accent4>
+      <a:accent5>
+        <a:srgbClr val="A02B93"/>
+      </a:accent5>
+      <a:accent6>
+        <a:srgbClr val="4EA72E"/>
+      </a:accent6>
+      <a:hlink>
+        <a:srgbClr val="467886"/>
+      </a:hlink>
+      <a:folHlink>
+        <a:srgbClr val="96607D"/>
+      </a:folHlink>
+    </a:clrScheme>
+    <a:fontScheme name="Office">
+      <a:majorFont>
+        <a:latin typeface="Aptos Display" panose="02110004020202020204"/>
+        <a:ea typeface=""/>
+        <a:cs typeface=""/>
+        <a:font script="Jpan" typeface="游ゴシック Light"/>
+        <a:font script="Hang" typeface="맑은 고딕"/>
+        <a:font script="Hans" typeface="等线 Light"/>
+        <a:font script="Hant" typeface="新細明體"/>
+        <a:font script="Arab" typeface="Times New Roman"/>
+        <a:font script="Hebr" typeface="Times New Roman"/>
+        <a:font script="Thai" typeface="Angsana New"/>
+        <a:font script="Ethi" typeface="Nyala"/>
+        <a:font script="Beng" typeface="Vrinda"/>
+        <a:font script="Gujr" typeface="Shruti"/>
+        <a:font script="Khmr" typeface="MoolBoran"/>
+        <a:font script="Knda" typeface="Tunga"/>
+        <a:font script="Guru" typeface="Raavi"/>
+        <a:font script="Cans" typeface="Euphemia"/>
+        <a:font script="Cher" typeface="Plantagenet Cherokee"/>
+        <a:font script="Yiii" typeface="Microsoft Yi Baiti"/>
+        <a:font script="Tibt" typeface="Microsoft Himalaya"/>
+        <a:font script="Thaa" typeface="MV Boli"/>
+        <a:font script="Deva" typeface="Mangal"/>
+        <a:font script="Telu" typeface="Gautami"/>
+        <a:font script="Taml" typeface="Latha"/>
+        <a:font script="Syrc" typeface="Estrangelo Edessa"/>
+        <a:font script="Orya" typeface="Kalinga"/>
+        <a:font script="Mlym" typeface="Kartika"/>
+        <a:font script="Laoo" typeface="DokChampa"/>
+        <a:font script="Sinh" typeface="Iskoola Pota"/>
+        <a:font script="Mong" typeface="Mongolian Baiti"/>
+        <a:font script="Viet" typeface="Times New Roman"/>
+        <a:font script="Uigh" typeface="Microsoft Uighur"/>
+        <a:font script="Geor" typeface="Sylfaen"/>
+        <a:font script="Armn" typeface="Arial"/>
+        <a:font script="Bugi" typeface="Leelawadee UI"/>
+        <a:font script="Bopo" typeface="Microsoft JhengHei"/>
+        <a:font script="Java" typeface="Javanese Text"/>
+        <a:font script="Lisu" typeface="Segoe UI"/>
+        <a:font script="Mymr" typeface="Myanmar Text"/>
+        <a:font script="Nkoo" typeface="Ebrima"/>
+        <a:font script="Olck" typeface="Nirmala UI"/>
+        <a:font script="Osma" typeface="Ebrima"/>
+        <a:font script="Phag" typeface="Phagspa"/>
+        <a:font script="Syrn" typeface="Estrangelo Edessa"/>
+        <a:font script="Syrj" typeface="Estrangelo Edessa"/>
+        <a:font script="Syre" typeface="Estrangelo Edessa"/>
+        <a:font script="Sora" typeface="Nirmala UI"/>
+        <a:font script="Tale" typeface="Microsoft Tai Le"/>
+        <a:font script="Talu" typeface="Microsoft New Tai Lue"/>
+        <a:font script="Tfng" typeface="Ebrima"/>
+      </a:majorFont>
+      <a:minorFont>
+        <a:latin typeface="Aptos" panose="02110004020202020204"/>
+        <a:ea typeface=""/>
+        <a:cs typeface=""/>
+        <a:font script="Jpan" typeface="游ゴシック"/>
+        <a:font script="Hang" typeface="맑은 고딕"/>
+        <a:font script="Hans" typeface="等线"/>
+        <a:font script="Hant" typeface="新細明體"/>
+        <a:font script="Arab" typeface="Arial"/>
+        <a:font script="Hebr" typeface="Arial"/>
+        <a:font script="Thai" typeface="Cordia New"/>
+        <a:font script="Ethi" typeface="Nyala"/>
+        <a:font script="Beng" typeface="Vrinda"/>
+        <a:font script="Gujr" typeface="Shruti"/>
+        <a:font script="Khmr" typeface="DaunPenh"/>
+        <a:font script="Knda" typeface="Tunga"/>
+        <a:font script="Guru" typeface="Raavi"/>
+        <a:font script="Cans" typeface="Euphemia"/>
+        <a:font script="Cher" typeface="Plantagenet Cherokee"/>
+        <a:font script="Yiii" typeface="Microsoft Yi Baiti"/>
+        <a:font script="Tibt" typeface="Microsoft Himalaya"/>
+        <a:font script="Thaa" typeface="MV Boli"/>
+        <a:font script="Deva" typeface="Mangal"/>
+        <a:font script="Telu" typeface="Gautami"/>
+        <a:font script="Taml" typeface="Latha"/>
+        <a:font script="Syrc" typeface="Estrangelo Edessa"/>
+        <a:font script="Orya" typeface="Kalinga"/>
+        <a:font script="Mlym" typeface="Kartika"/>
+        <a:font script="Laoo" typeface="DokChampa"/>
+        <a:font script="Sinh" typeface="Iskoola Pota"/>
+        <a:font script="Mong" typeface="Mongolian Baiti"/>
+        <a:font script="Viet" typeface="Arial"/>
+        <a:font script="Uigh" typeface="Microsoft Uighur"/>
+        <a:font script="Geor" typeface="Sylfaen"/>
+        <a:font script="Armn" typeface="Arial"/>
+        <a:font script="Bugi" typeface="Leelawadee UI"/>
+        <a:font script="Bopo" typeface="Microsoft JhengHei"/>
+        <a:font script="Java" typeface="Javanese Text"/>
+        <a:font script="Lisu" typeface="Segoe UI"/>
+        <a:font script="Mymr" typeface="Myanmar Text"/>
+        <a:font script="Nkoo" typeface="Ebrima"/>
+        <a:font script="Olck" typeface="Nirmala UI"/>
+        <a:font script="Osma" typeface="Ebrima"/>
+        <a:font script="Phag" typeface="Phagspa"/>
+        <a:font script="Syrn" typeface="Estrangelo Edessa"/>
+        <a:font script="Syrj" typeface="Estrangelo Edessa"/>
+        <a:font script="Syre" typeface="Estrangelo Edessa"/>
+        <a:font script="Sora" typeface="Nirmala UI"/>
+        <a:font script="Tale" typeface="Microsoft Tai Le"/>
+        <a:font script="Talu" typeface="Microsoft New Tai Lue"/>
+        <a:font script="Tfng" typeface="Ebrima"/>
+      </a:minorFont>
+    </a:fontScheme>
+    <a:fmtScheme name="Office">
+      <a:fillStyleLst>
+        <a:solidFill>
+          <a:schemeClr val="phClr"/>
+        </a:solidFill>
+        <a:gradFill rotWithShape="1">
+          <a:gsLst>
+            <a:gs pos="0">
+              <a:schemeClr val="phClr">
+                <a:lumMod val="110000"/>
+                <a:satMod val="105000"/>
+                <a:tint val="67000"/>
+              </a:schemeClr>
+            </a:gs>
+            <a:gs pos="50000">
+              <a:schemeClr val="phClr">
+                <a:lumMod val="105000"/>
+                <a:satMod val="103000"/>
+                <a:tint val="73000"/>
+              </a:schemeClr>
+            </a:gs>
+            <a:gs pos="100000">
+              <a:schemeClr val="phClr">
+                <a:lumMod val="105000"/>
+                <a:satMod val="109000"/>
+                <a:tint val="81000"/>
+              </a:schemeClr>
+            </a:gs>
+          </a:gsLst>
+          <a:lin ang="5400000" scaled="0"/>
+        </a:gradFill>
+        <a:gradFill rotWithShape="1">
+          <a:gsLst>
+            <a:gs pos="0">
+              <a:schemeClr val="phClr">
+                <a:satMod val="103000"/>
+                <a:lumMod val="102000"/>
+                <a:tint val="94000"/>
+              </a:schemeClr>
+            </a:gs>
+            <a:gs pos="50000">
+              <a:schemeClr val="phClr">
+                <a:satMod val="110000"/>
+                <a:lumMod val="100000"/>
+                <a:shade val="100000"/>
+              </a:schemeClr>
+            </a:gs>
+            <a:gs pos="100000">
+              <a:schemeClr val="phClr">
+                <a:lumMod val="99000"/>
+                <a:satMod val="120000"/>
+                <a:shade val="78000"/>
+              </a:schemeClr>
+            </a:gs>
+          </a:gsLst>
+          <a:lin ang="5400000" scaled="0"/>
+        </a:gradFill>
+      </a:fillStyleLst>
+      <a:lnStyleLst>
+        <a:ln w="12700" cap="flat" cmpd="sng" algn="ctr">
+          <a:solidFill>
+            <a:schemeClr val="phClr"/>
+          </a:solidFill>
+          <a:prstDash val="solid"/>
+          <a:miter lim="800000"/>
+        </a:ln>
+        <a:ln w="19050" cap="flat" cmpd="sng" algn="ctr">
+          <a:solidFill>
+            <a:schemeClr val="phClr"/>
+          </a:solidFill>
+          <a:prstDash val="solid"/>
+          <a:miter lim="800000"/>
+        </a:ln>
+        <a:ln w="25400" cap="flat" cmpd="sng" algn="ctr">
+          <a:solidFill>
+            <a:schemeClr val="phClr"/>
+          </a:solidFill>
+          <a:prstDash val="solid"/>
+          <a:miter lim="800000"/>
+        </a:ln>
+      </a:lnStyleLst>
+      <a:effectStyleLst>
+        <a:effectStyle>
+          <a:effectLst/>
+        </a:effectStyle>
+        <a:effectStyle>
+          <a:effectLst/>
+        </a:effectStyle>
+        <a:effectStyle>
+          <a:effectLst>
+            <a:outerShdw blurRad="57150" dist="19050" dir="5400000" algn="ctr" rotWithShape="0">
+              <a:srgbClr val="000000">
+                <a:alpha val="63000"/>
+              </a:srgbClr>
+            </a:outerShdw>
+          </a:effectLst>
+        </a:effectStyle>
+      </a:effectStyleLst>
+      <a:bgFillStyleLst>
+        <a:solidFill>
+          <a:schemeClr val="phClr"/>
+        </a:solidFill>
+        <a:solidFill>
+          <a:schemeClr val="phClr">
+            <a:tint val="95000"/>
+            <a:satMod val="170000"/>
+          </a:schemeClr>
+        </a:solidFill>
+        <a:gradFill rotWithShape="1">
+          <a:gsLst>
+            <a:gs pos="0">
+              <a:schemeClr val="phClr">
+                <a:tint val="93000"/>
+                <a:satMod val="150000"/>
+                <a:shade val="98000"/>
+                <a:lumMod val="102000"/>
+              </a:schemeClr>
+            </a:gs>
+            <a:gs pos="50000">
+              <a:schemeClr val="phClr">
+                <a:tint val="98000"/>
+                <a:satMod val="130000"/>
+                <a:shade val="90000"/>
+                <a:lumMod val="103000"/>
+              </a:schemeClr>
+            </a:gs>
+            <a:gs pos="100000">
+              <a:schemeClr val="phClr">
+                <a:shade val="63000"/>
+                <a:satMod val="120000"/>
+              </a:schemeClr>
+            </a:gs>
+          </a:gsLst>
+          <a:lin ang="5400000" scaled="0"/>
+        </a:gradFill>
+      </a:bgFillStyleLst>
+    </a:fmtScheme>
+  </a:themeElements>
+  <a:objectDefaults>
+    <a:lnDef>
+      <a:spPr/>
+      <a:bodyPr/>
+      <a:lstStyle/>
+      <a:style>
+        <a:lnRef idx="2">
+          <a:schemeClr val="accent1"/>
+        </a:lnRef>
+        <a:fillRef idx="0">
+          <a:schemeClr val="accent1"/>
+        </a:fillRef>
+        <a:effectRef idx="1">
+          <a:schemeClr val="accent1"/>
+        </a:effectRef>
+        <a:fontRef idx="minor">
+          <a:schemeClr val="tx1"/>
+        </a:fontRef>
+      </a:style>
+    </a:lnDef>
+  </a:objectDefaults>
+  <a:extraClrSchemeLst/>
+  <a:extLst>
+    <a:ext uri="{05A4C25C-085E-4340-85A3-A5531E510DB2}">
+      <thm15:themeFamily xmlns:thm15="http://schemas.microsoft.com/office/thememl/2012/main" name="Office Theme" id="{2E142A2C-CD16-42D6-873A-C26D2A0506FA}" vid="{1BDDFF52-6CD6-40A5-AB3C-68EB2F1E4D0A}"/>
+    </a:ext>
+  </a:extLst>
+</a:theme>
+</file>
+
 <file path=customXml/item1.xml><?xml version="1.0" encoding="utf-8"?>
+<p:properties xmlns:p="http://schemas.microsoft.com/office/2006/metadata/properties" xmlns:xsi="http://www.w3.org/2001/XMLSchema-instance" xmlns:pc="http://schemas.microsoft.com/office/infopath/2007/PartnerControls">
+  <documentManagement>
+    <_activity xmlns="830fda85-f4b0-4700-8416-741e05314721" xsi:nil="true"/>
+  </documentManagement>
+</p:properties>
+</file>
+
+<file path=customXml/item2.xml><?xml version="1.0" encoding="utf-8"?>
+<?mso-contentType ?>
+<FormTemplates xmlns="http://schemas.microsoft.com/sharepoint/v3/contenttype/forms">
+  <Display>DocumentLibraryForm</Display>
+  <Edit>DocumentLibraryForm</Edit>
+  <New>DocumentLibraryForm</New>
+</FormTemplates>
+</file>
+
+<file path=customXml/item3.xml><?xml version="1.0" encoding="utf-8"?>
 <ct:contentTypeSchema xmlns:ct="http://schemas.microsoft.com/office/2006/metadata/contentType" xmlns:ma="http://schemas.microsoft.com/office/2006/metadata/properties/metaAttributes" ct:_="" ma:_="" ma:contentTypeName="Document" ma:contentTypeID="0x010100F00EB484D340114EBA8EB2629E4692C6" ma:contentTypeVersion="17" ma:contentTypeDescription="Create a new document." ma:contentTypeScope="" ma:versionID="f2acec87b00981f20cb2346e1a845612">
   <xsd:schema xmlns:xsd="http://www.w3.org/2001/XMLSchema" xmlns:xs="http://www.w3.org/2001/XMLSchema" xmlns:p="http://schemas.microsoft.com/office/2006/metadata/properties" xmlns:ns3="830fda85-f4b0-4700-8416-741e05314721" xmlns:ns4="b0ad532f-a9f6-4653-a973-c0c9c872f875" targetNamespace="http://schemas.microsoft.com/office/2006/metadata/properties" ma:root="true" ma:fieldsID="36ac933679a362702daf5fa895e0dd27" ns3:_="" ns4:_="">
     <xsd:import namespace="830fda85-f4b0-4700-8416-741e05314721"/>
@@ -4558,24 +6525,32 @@
 </ct:contentTypeSchema>
 </file>
 
-<file path=customXml/item2.xml><?xml version="1.0" encoding="utf-8"?>
-<?mso-contentType ?>
-<FormTemplates xmlns="http://schemas.microsoft.com/sharepoint/v3/contenttype/forms">
-  <Display>DocumentLibraryForm</Display>
-  <Edit>DocumentLibraryForm</Edit>
-  <New>DocumentLibraryForm</New>
-</FormTemplates>
+<file path=customXml/itemProps1.xml><?xml version="1.0" encoding="utf-8"?>
+<ds:datastoreItem xmlns:ds="http://schemas.openxmlformats.org/officeDocument/2006/customXml" ds:itemID="{9ABE1524-713E-44BA-A5CD-E1B93E70488D}">
+  <ds:schemaRefs>
+    <ds:schemaRef ds:uri="830fda85-f4b0-4700-8416-741e05314721"/>
+    <ds:schemaRef ds:uri="http://schemas.microsoft.com/office/2006/metadata/properties"/>
+    <ds:schemaRef ds:uri="http://schemas.microsoft.com/office/infopath/2007/PartnerControls"/>
+    <ds:schemaRef ds:uri="http://schemas.microsoft.com/office/2006/documentManagement/types"/>
+    <ds:schemaRef ds:uri="http://purl.org/dc/terms/"/>
+    <ds:schemaRef ds:uri="http://purl.org/dc/elements/1.1/"/>
+    <ds:schemaRef ds:uri="b0ad532f-a9f6-4653-a973-c0c9c872f875"/>
+    <ds:schemaRef ds:uri="http://purl.org/dc/dcmitype/"/>
+    <ds:schemaRef ds:uri="http://schemas.openxmlformats.org/package/2006/metadata/core-properties"/>
+    <ds:schemaRef ds:uri="http://www.w3.org/XML/1998/namespace"/>
+  </ds:schemaRefs>
+</ds:datastoreItem>
 </file>
 
-<file path=customXml/item3.xml><?xml version="1.0" encoding="utf-8"?>
-<p:properties xmlns:p="http://schemas.microsoft.com/office/2006/metadata/properties" xmlns:xsi="http://www.w3.org/2001/XMLSchema-instance" xmlns:pc="http://schemas.microsoft.com/office/infopath/2007/PartnerControls">
-  <documentManagement>
-    <_activity xmlns="830fda85-f4b0-4700-8416-741e05314721" xsi:nil="true"/>
-  </documentManagement>
-</p:properties>
+<file path=customXml/itemProps2.xml><?xml version="1.0" encoding="utf-8"?>
+<ds:datastoreItem xmlns:ds="http://schemas.openxmlformats.org/officeDocument/2006/customXml" ds:itemID="{56B0F3D0-3AA3-4445-B365-11E0C14CB764}">
+  <ds:schemaRefs>
+    <ds:schemaRef ds:uri="http://schemas.microsoft.com/sharepoint/v3/contenttype/forms"/>
+  </ds:schemaRefs>
+</ds:datastoreItem>
 </file>
 
-<file path=customXml/itemProps1.xml><?xml version="1.0" encoding="utf-8"?>
+<file path=customXml/itemProps3.xml><?xml version="1.0" encoding="utf-8"?>
 <ds:datastoreItem xmlns:ds="http://schemas.openxmlformats.org/officeDocument/2006/customXml" ds:itemID="{0DF57D0E-18F7-4650-9082-9DE9FD6904BF}">
   <ds:schemaRefs>
     <ds:schemaRef ds:uri="http://schemas.microsoft.com/office/2006/metadata/contentType"/>
@@ -4592,29 +6567,4 @@
     <ds:schemaRef ds:uri="http://schemas.microsoft.com/internal/obd"/>
   </ds:schemaRefs>
 </ds:datastoreItem>
-</file>
-
-<file path=customXml/itemProps2.xml><?xml version="1.0" encoding="utf-8"?>
-<ds:datastoreItem xmlns:ds="http://schemas.openxmlformats.org/officeDocument/2006/customXml" ds:itemID="{56B0F3D0-3AA3-4445-B365-11E0C14CB764}">
-  <ds:schemaRefs>
-    <ds:schemaRef ds:uri="http://schemas.microsoft.com/sharepoint/v3/contenttype/forms"/>
-  </ds:schemaRefs>
-</ds:datastoreItem>
-</file>
-
-<file path=customXml/itemProps3.xml><?xml version="1.0" encoding="utf-8"?>
-<ds:datastoreItem xmlns:ds="http://schemas.openxmlformats.org/officeDocument/2006/customXml" ds:itemID="{9ABE1524-713E-44BA-A5CD-E1B93E70488D}">
-  <ds:schemaRefs>
-    <ds:schemaRef ds:uri="830fda85-f4b0-4700-8416-741e05314721"/>
-    <ds:schemaRef ds:uri="http://schemas.microsoft.com/office/2006/metadata/properties"/>
-    <ds:schemaRef ds:uri="http://schemas.microsoft.com/office/infopath/2007/PartnerControls"/>
-    <ds:schemaRef ds:uri="http://schemas.microsoft.com/office/2006/documentManagement/types"/>
-    <ds:schemaRef ds:uri="http://purl.org/dc/terms/"/>
-    <ds:schemaRef ds:uri="http://purl.org/dc/elements/1.1/"/>
-    <ds:schemaRef ds:uri="b0ad532f-a9f6-4653-a973-c0c9c872f875"/>
-    <ds:schemaRef ds:uri="http://purl.org/dc/dcmitype/"/>
-    <ds:schemaRef ds:uri="http://schemas.openxmlformats.org/package/2006/metadata/core-properties"/>
-    <ds:schemaRef ds:uri="http://www.w3.org/XML/1998/namespace"/>
-  </ds:schemaRefs>
-</ds:datastoreItem>
 </file>
</xml_diff>